<commit_message>
Re-export the EV market-priorities decks after the P10 tier-note bounds fix
The checker now measures paragraphs that open with an inline run, which
exposed the 96 px tier-note bounds on page 10 (d526ef3 raised them to
112 px). Both exports are rebuilt from the corrected page so the shipped
PPTX matches svg_output; POSTFLIGHT passed on both.

Co-Authored-By: Claude Fable 5.1 <noreply@anthropic.com>
Claude-Session: https://claude.ai/code/session_01Eq2teFYQN42gQBLKGur5HD
</commit_message>
<xml_diff>
--- a/examples/ppt169_ev_market_priorities/exports/ppt169_ev_market_priorities_native_charts_tables.pptx
+++ b/examples/ppt169_ev_market_priorities/exports/ppt169_ev_market_priorities_native_charts_tables.pptx
@@ -23,11 +23,11 @@
     <p:sldId id="268" r:id="rId19"/>
     <p:sldId id="269" r:id="rId20"/>
   </p:sldIdLst>
-  <p:sldSz cx="12192000" cy="6858000" type="screen4x3"/>
+  <p:sldSz cx="12192000" cy="6858000" type="screen16x9"/>
   <p:notesSz cx="6858000" cy="9144000"/>
   <p:defaultTextStyle>
     <a:defPPr>
-      <a:defRPr lang="en-US"/>
+      <a:defRPr lang="zh-CN"/>
     </a:defPPr>
     <a:lvl1pPr marL="0" algn="l" defTabSz="457200" rtl="0" eaLnBrk="1" latinLnBrk="0" hangingPunct="1">
       <a:defRPr sz="1800" kern="1200">
@@ -6539,10 +6539,10 @@
           <a:lstStyle/>
           <a:p>
             <a:fld id="{5BCAD085-E8A6-8845-BD4E-CB4CCA059FC4}" type="datetimeFigureOut">
-              <a:rPr lang="en-US" smtClean="0"/>
+              <a:rPr lang="zh-CN" smtClean="0"/>
               <a:t>1/27/13</a:t>
             </a:fld>
-            <a:endParaRPr lang="en-US"/>
+            <a:endParaRPr lang="zh-CN"/>
           </a:p>
         </p:txBody>
       </p:sp>
@@ -6561,7 +6561,7 @@
           <a:bodyPr/>
           <a:lstStyle/>
           <a:p>
-            <a:endParaRPr lang="en-US"/>
+            <a:endParaRPr lang="zh-CN"/>
           </a:p>
         </p:txBody>
       </p:sp>
@@ -6581,10 +6581,10 @@
           <a:lstStyle/>
           <a:p>
             <a:fld id="{C1FF6DA9-008F-8B48-92A6-B652298478BF}" type="slidenum">
-              <a:rPr lang="en-US" smtClean="0"/>
+              <a:rPr lang="zh-CN" smtClean="0"/>
               <a:t>‹#›</a:t>
             </a:fld>
-            <a:endParaRPr lang="en-US"/>
+            <a:endParaRPr lang="zh-CN"/>
           </a:p>
         </p:txBody>
       </p:sp>
@@ -6652,10 +6652,10 @@
           </a:lstStyle>
           <a:p>
             <a:fld id="{5BCAD085-E8A6-8845-BD4E-CB4CCA059FC4}" type="datetimeFigureOut">
-              <a:rPr lang="en-US" smtClean="0"/>
+              <a:rPr lang="zh-CN" smtClean="0"/>
               <a:t>1/27/13</a:t>
             </a:fld>
-            <a:endParaRPr lang="en-US"/>
+            <a:endParaRPr lang="zh-CN"/>
           </a:p>
         </p:txBody>
       </p:sp>
@@ -6692,7 +6692,7 @@
             </a:lvl1pPr>
           </a:lstStyle>
           <a:p>
-            <a:endParaRPr lang="en-US"/>
+            <a:endParaRPr lang="zh-CN"/>
           </a:p>
         </p:txBody>
       </p:sp>
@@ -6730,10 +6730,10 @@
           </a:lstStyle>
           <a:p>
             <a:fld id="{C1FF6DA9-008F-8B48-92A6-B652298478BF}" type="slidenum">
-              <a:rPr lang="en-US" smtClean="0"/>
+              <a:rPr lang="zh-CN" smtClean="0"/>
               <a:t>‹#›</a:t>
             </a:fld>
-            <a:endParaRPr lang="en-US"/>
+            <a:endParaRPr lang="zh-CN"/>
           </a:p>
         </p:txBody>
       </p:sp>
@@ -6899,7 +6899,7 @@
     </p:bodyStyle>
     <p:otherStyle>
       <a:defPPr>
-        <a:defRPr lang="en-US"/>
+        <a:defRPr lang="zh-CN"/>
       </a:defPPr>
       <a:lvl1pPr marL="0" algn="l" defTabSz="457200" rtl="0" eaLnBrk="1" latinLnBrk="0" hangingPunct="1">
         <a:defRPr sz="1050" kern="1200">
@@ -7023,7 +7023,7 @@
       </p:grpSpPr>
       <p:grpSp>
         <p:nvGrpSpPr>
-          <p:cNvPr id="5" name="Group 5"/>
+          <p:cNvPr id="5" name="cover-meta"/>
           <p:cNvGrpSpPr/>
           <p:nvPr/>
         </p:nvGrpSpPr>
@@ -7044,7 +7044,7 @@
           <p:spPr>
             <a:xfrm>
               <a:off x="452438" y="349091"/>
-              <a:ext cx="4284927" cy="161925"/>
+              <a:ext cx="4227501" cy="161925"/>
             </a:xfrm>
             <a:prstGeom prst="rect">
               <a:avLst/>
@@ -7140,7 +7140,7 @@
       </p:grpSp>
       <p:grpSp>
         <p:nvGrpSpPr>
-          <p:cNvPr id="10" name="Group 10"/>
+          <p:cNvPr id="10" name="cover-title-stack"/>
           <p:cNvGrpSpPr/>
           <p:nvPr/>
         </p:nvGrpSpPr>
@@ -7327,7 +7327,7 @@
       </p:grpSp>
       <p:grpSp>
         <p:nvGrpSpPr>
-          <p:cNvPr id="21" name="Group 21"/>
+          <p:cNvPr id="21" name="cover-questions"/>
           <p:cNvGrpSpPr/>
           <p:nvPr/>
         </p:nvGrpSpPr>
@@ -7409,8 +7409,8 @@
           </p:nvSpPr>
           <p:spPr>
             <a:xfrm>
-              <a:off x="499484" y="3486150"/>
-              <a:ext cx="67832" cy="147638"/>
+              <a:off x="500559" y="3486150"/>
+              <a:ext cx="65682" cy="147638"/>
             </a:xfrm>
             <a:prstGeom prst="rect">
               <a:avLst/>
@@ -7511,8 +7511,8 @@
           </p:nvSpPr>
           <p:spPr>
             <a:xfrm>
-              <a:off x="499484" y="3771900"/>
-              <a:ext cx="67832" cy="147638"/>
+              <a:off x="500559" y="3771900"/>
+              <a:ext cx="65682" cy="147638"/>
             </a:xfrm>
             <a:prstGeom prst="rect">
               <a:avLst/>
@@ -7552,7 +7552,7 @@
           <p:spPr>
             <a:xfrm>
               <a:off x="680466" y="3753802"/>
-              <a:ext cx="3901288" cy="205359"/>
+              <a:ext cx="3717265" cy="205359"/>
             </a:xfrm>
             <a:prstGeom prst="rect">
               <a:avLst/>
@@ -7613,8 +7613,8 @@
           </p:nvSpPr>
           <p:spPr>
             <a:xfrm>
-              <a:off x="499484" y="4057650"/>
-              <a:ext cx="67832" cy="147638"/>
+              <a:off x="500559" y="4057650"/>
+              <a:ext cx="65682" cy="147638"/>
             </a:xfrm>
             <a:prstGeom prst="rect">
               <a:avLst/>
@@ -7688,7 +7688,7 @@
       </p:grpSp>
       <p:grpSp>
         <p:nvGrpSpPr>
-          <p:cNvPr id="31" name="Group 31"/>
+          <p:cNvPr id="31" name="cover-figures"/>
           <p:cNvGrpSpPr/>
           <p:nvPr/>
         </p:nvGrpSpPr>
@@ -7745,7 +7745,7 @@
           <p:spPr>
             <a:xfrm>
               <a:off x="7795260" y="1543050"/>
-              <a:ext cx="1521733" cy="586740"/>
+              <a:ext cx="1366287" cy="586740"/>
             </a:xfrm>
             <a:prstGeom prst="rect">
               <a:avLst/>
@@ -7874,7 +7874,7 @@
           <p:spPr>
             <a:xfrm>
               <a:off x="7795260" y="2533650"/>
-              <a:ext cx="814978" cy="586740"/>
+              <a:ext cx="838846" cy="586740"/>
             </a:xfrm>
             <a:prstGeom prst="rect">
               <a:avLst/>
@@ -7914,7 +7914,7 @@
           <p:spPr>
             <a:xfrm>
               <a:off x="7805738" y="2950845"/>
-              <a:ext cx="1978343" cy="176212"/>
+              <a:ext cx="1978342" cy="176212"/>
             </a:xfrm>
             <a:prstGeom prst="rect">
               <a:avLst/>
@@ -7992,7 +7992,7 @@
           <p:spPr>
             <a:xfrm>
               <a:off x="7795260" y="3524250"/>
-              <a:ext cx="1055275" cy="586740"/>
+              <a:ext cx="1040695" cy="586740"/>
             </a:xfrm>
             <a:prstGeom prst="rect">
               <a:avLst/>
@@ -8077,7 +8077,7 @@
       </p:grpSp>
       <p:grpSp>
         <p:nvGrpSpPr>
-          <p:cNvPr id="40" name="Group 40"/>
+          <p:cNvPr id="40" name="cover-structure"/>
           <p:cNvGrpSpPr/>
           <p:nvPr/>
         </p:nvGrpSpPr>
@@ -8174,7 +8174,7 @@
           <p:spPr>
             <a:xfrm>
               <a:off x="451866" y="5182552"/>
-              <a:ext cx="936517" cy="205359"/>
+              <a:ext cx="929732" cy="205359"/>
             </a:xfrm>
             <a:prstGeom prst="rect">
               <a:avLst/>
@@ -8281,7 +8281,7 @@
           <p:spPr>
             <a:xfrm>
               <a:off x="4261866" y="5182552"/>
-              <a:ext cx="1092003" cy="205359"/>
+              <a:ext cx="1086971" cy="205359"/>
             </a:xfrm>
             <a:prstGeom prst="rect">
               <a:avLst/>
@@ -8388,7 +8388,7 @@
           <p:spPr>
             <a:xfrm>
               <a:off x="8071866" y="5182552"/>
-              <a:ext cx="1092003" cy="205359"/>
+              <a:ext cx="1086971" cy="205359"/>
             </a:xfrm>
             <a:prstGeom prst="rect">
               <a:avLst/>
@@ -8799,7 +8799,7 @@
       </p:grpSpPr>
       <p:grpSp>
         <p:nvGrpSpPr>
-          <p:cNvPr id="5" name="Group 5"/>
+          <p:cNvPr id="5" name="tracker"/>
           <p:cNvGrpSpPr/>
           <p:nvPr/>
         </p:nvGrpSpPr>
@@ -8916,7 +8916,7 @@
       </p:grpSp>
       <p:grpSp>
         <p:nvGrpSpPr>
-          <p:cNvPr id="7" name="Group 7"/>
+          <p:cNvPr id="7" name="title"/>
           <p:cNvGrpSpPr/>
           <p:nvPr/>
         </p:nvGrpSpPr>
@@ -8987,7 +8987,7 @@
       </p:grpSp>
       <p:grpSp>
         <p:nvGrpSpPr>
-          <p:cNvPr id="9" name="Group 9"/>
+          <p:cNvPr id="9" name="unit-line"/>
           <p:cNvGrpSpPr/>
           <p:nvPr/>
         </p:nvGrpSpPr>
@@ -13110,7 +13110,7 @@
       </p:graphicFrame>
       <p:grpSp>
         <p:nvGrpSpPr>
-          <p:cNvPr id="20" name="Group 20"/>
+          <p:cNvPr id="20" name="tier-totals"/>
           <p:cNvGrpSpPr/>
           <p:nvPr/>
         </p:nvGrpSpPr>
@@ -13131,7 +13131,7 @@
           <p:spPr>
             <a:xfrm>
               <a:off x="452438" y="5130641"/>
-              <a:ext cx="2896397" cy="161925"/>
+              <a:ext cx="2888396" cy="161925"/>
             </a:xfrm>
             <a:prstGeom prst="rect">
               <a:avLst/>
@@ -13207,7 +13207,7 @@
           <p:spPr>
             <a:xfrm>
               <a:off x="448818" y="5346382"/>
-              <a:ext cx="658144" cy="322707"/>
+              <a:ext cx="572649" cy="322707"/>
             </a:xfrm>
             <a:prstGeom prst="rect">
               <a:avLst/>
@@ -13287,7 +13287,7 @@
           <p:spPr>
             <a:xfrm>
               <a:off x="2227136" y="5346382"/>
-              <a:ext cx="273316" cy="322707"/>
+              <a:ext cx="263854" cy="322707"/>
             </a:xfrm>
             <a:prstGeom prst="rect">
               <a:avLst/>
@@ -13367,7 +13367,7 @@
           <p:spPr>
             <a:xfrm>
               <a:off x="4004500" y="5346382"/>
-              <a:ext cx="401592" cy="322707"/>
+              <a:ext cx="387398" cy="322707"/>
             </a:xfrm>
             <a:prstGeom prst="rect">
               <a:avLst/>
@@ -13441,7 +13441,7 @@
       </p:grpSp>
       <p:grpSp>
         <p:nvGrpSpPr>
-          <p:cNvPr id="27" name="Group 27"/>
+          <p:cNvPr id="24" name="tier-note"/>
           <p:cNvGrpSpPr/>
           <p:nvPr/>
         </p:nvGrpSpPr>
@@ -13538,7 +13538,7 @@
           <p:spPr>
             <a:xfrm>
               <a:off x="6090666" y="5373052"/>
-              <a:ext cx="3827145" cy="205359"/>
+              <a:ext cx="3791140" cy="719709"/>
             </a:xfrm>
             <a:prstGeom prst="rect">
               <a:avLst/>
@@ -13554,7 +13554,11 @@
             </a:bodyPr>
             <a:lstStyle/>
             <a:p>
-              <a:pPr algn="l"/>
+              <a:pPr algn="l">
+                <a:lnSpc>
+                  <a:spcPts val="1350"/>
+                </a:lnSpc>
+              </a:pPr>
               <a:r>
                 <a:rPr lang="zh-CN" sz="1050" b="1" dirty="0">
                   <a:solidFill>
@@ -13577,35 +13581,7 @@
                 </a:rPr>
                 <a:t xml:space="preserve"> 2026–28 增量投入主战场:中国守存量、东南亚抢窗口、</a:t>
               </a:r>
-            </a:p>
-          </p:txBody>
-        </p:sp>
-        <p:sp>
-          <p:nvSpPr>
-            <p:cNvPr id="24" name="TextBox 24"/>
-            <p:cNvSpPr txBox="1"/>
-            <p:nvPr/>
-          </p:nvSpPr>
-          <p:spPr>
-            <a:xfrm>
-              <a:off x="6090666" y="5544502"/>
-              <a:ext cx="1784623" cy="205359"/>
-            </a:xfrm>
-            <a:prstGeom prst="rect">
-              <a:avLst/>
-            </a:prstGeom>
-            <a:noFill/>
-            <a:ln>
-              <a:noFill/>
-            </a:ln>
-          </p:spPr>
-          <p:txBody>
-            <a:bodyPr wrap="none" lIns="0" tIns="0" rIns="0" bIns="0" anchor="t" anchorCtr="0">
-              <a:spAutoFit/>
-            </a:bodyPr>
-            <a:lstStyle/>
-            <a:p>
-              <a:pPr algn="l"/>
+              <a:br/>
               <a:r>
                 <a:rPr lang="zh-CN" sz="1050" dirty="0">
                   <a:solidFill>
@@ -13617,35 +13593,7 @@
                 </a:rPr>
                 <a:t>英德是欧洲仅有的确定增量;</a:t>
               </a:r>
-            </a:p>
-          </p:txBody>
-        </p:sp>
-        <p:sp>
-          <p:nvSpPr>
-            <p:cNvPr id="25" name="TextBox 25"/>
-            <p:cNvSpPr txBox="1"/>
-            <p:nvPr/>
-          </p:nvSpPr>
-          <p:spPr>
-            <a:xfrm>
-              <a:off x="6090666" y="5715952"/>
-              <a:ext cx="3310280" cy="205359"/>
-            </a:xfrm>
-            <a:prstGeom prst="rect">
-              <a:avLst/>
-            </a:prstGeom>
-            <a:noFill/>
-            <a:ln>
-              <a:noFill/>
-            </a:ln>
-          </p:spPr>
-          <p:txBody>
-            <a:bodyPr wrap="none" lIns="0" tIns="0" rIns="0" bIns="0" anchor="t" anchorCtr="0">
-              <a:spAutoFit/>
-            </a:bodyPr>
-            <a:lstStyle/>
-            <a:p>
-              <a:pPr algn="l"/>
+              <a:br/>
               <a:r>
                 <a:rPr lang="zh-CN" sz="1050" b="1" dirty="0">
                   <a:solidFill>
@@ -13668,35 +13616,7 @@
                 </a:rPr>
                 <a:t xml:space="preserve"> 以 PHEV 试点验证后择机放量,试点规模受控;</a:t>
               </a:r>
-            </a:p>
-          </p:txBody>
-        </p:sp>
-        <p:sp>
-          <p:nvSpPr>
-            <p:cNvPr id="26" name="TextBox 26"/>
-            <p:cNvSpPr txBox="1"/>
-            <p:nvPr/>
-          </p:nvSpPr>
-          <p:spPr>
-            <a:xfrm>
-              <a:off x="6090666" y="5887402"/>
-              <a:ext cx="4017969" cy="205359"/>
-            </a:xfrm>
-            <a:prstGeom prst="rect">
-              <a:avLst/>
-            </a:prstGeom>
-            <a:noFill/>
-            <a:ln>
-              <a:noFill/>
-            </a:ln>
-          </p:spPr>
-          <p:txBody>
-            <a:bodyPr wrap="none" lIns="0" tIns="0" rIns="0" bIns="0" anchor="t" anchorCtr="0">
-              <a:spAutoFit/>
-            </a:bodyPr>
-            <a:lstStyle/>
-            <a:p>
-              <a:pPr algn="l"/>
+              <a:br/>
               <a:r>
                 <a:rPr lang="zh-CN" sz="1050" b="1" dirty="0">
                   <a:solidFill>
@@ -13725,7 +13645,7 @@
       </p:grpSp>
       <p:grpSp>
         <p:nvGrpSpPr>
-          <p:cNvPr id="32" name="Group 32"/>
+          <p:cNvPr id="29" name="footer"/>
           <p:cNvGrpSpPr/>
           <p:nvPr/>
         </p:nvGrpSpPr>
@@ -13739,14 +13659,14 @@
         </p:grpSpPr>
         <p:sp>
           <p:nvSpPr>
-            <p:cNvPr id="28" name="TextBox 28"/>
+            <p:cNvPr id="25" name="TextBox 25"/>
             <p:cNvSpPr txBox="1"/>
             <p:nvPr/>
           </p:nvSpPr>
           <p:spPr>
             <a:xfrm>
               <a:off x="452438" y="6205538"/>
-              <a:ext cx="6367653" cy="147638"/>
+              <a:ext cx="6111335" cy="147638"/>
             </a:xfrm>
             <a:prstGeom prst="rect">
               <a:avLst/>
@@ -13779,14 +13699,14 @@
         </p:sp>
         <p:sp>
           <p:nvSpPr>
-            <p:cNvPr id="29" name="TextBox 29"/>
+            <p:cNvPr id="26" name="TextBox 26"/>
             <p:cNvSpPr txBox="1"/>
             <p:nvPr/>
           </p:nvSpPr>
           <p:spPr>
             <a:xfrm>
               <a:off x="452438" y="6338888"/>
-              <a:ext cx="6074283" cy="147638"/>
+              <a:ext cx="5765387" cy="147638"/>
             </a:xfrm>
             <a:prstGeom prst="rect">
               <a:avLst/>
@@ -13819,14 +13739,14 @@
         </p:sp>
         <p:sp>
           <p:nvSpPr>
-            <p:cNvPr id="30" name="TextBox 30"/>
+            <p:cNvPr id="27" name="TextBox 27"/>
             <p:cNvSpPr txBox="1"/>
             <p:nvPr/>
           </p:nvSpPr>
           <p:spPr>
             <a:xfrm>
               <a:off x="452438" y="6491288"/>
-              <a:ext cx="5731497" cy="147638"/>
+              <a:ext cx="5691664" cy="147638"/>
             </a:xfrm>
             <a:prstGeom prst="rect">
               <a:avLst/>
@@ -13859,14 +13779,14 @@
         </p:sp>
         <p:sp>
           <p:nvSpPr>
-            <p:cNvPr id="31" name="TextBox 31"/>
+            <p:cNvPr id="28" name="TextBox 28"/>
             <p:cNvSpPr txBox="1"/>
             <p:nvPr/>
           </p:nvSpPr>
           <p:spPr>
             <a:xfrm>
-              <a:off x="11618976" y="6491288"/>
-              <a:ext cx="120586" cy="147638"/>
+              <a:off x="11617724" y="6491288"/>
+              <a:ext cx="121838" cy="147638"/>
             </a:xfrm>
             <a:prstGeom prst="rect">
               <a:avLst/>
@@ -14075,7 +13995,7 @@
                                           </p:stCondLst>
                                         </p:cTn>
                                         <p:tgtEl>
-                                          <p:spTgt spid="27"/>
+                                          <p:spTgt spid="24"/>
                                         </p:tgtEl>
                                         <p:attrNameLst>
                                           <p:attrName>style.visibility</p:attrName>
@@ -14089,7 +14009,7 @@
                                       <p:cBhvr>
                                         <p:cTn id="19" dur="300"/>
                                         <p:tgtEl>
-                                          <p:spTgt spid="27"/>
+                                          <p:spTgt spid="24"/>
                                         </p:tgtEl>
                                       </p:cBhvr>
                                     </p:animEffect>
@@ -14154,7 +14074,7 @@
       </p:grpSpPr>
       <p:grpSp>
         <p:nvGrpSpPr>
-          <p:cNvPr id="5" name="Group 5"/>
+          <p:cNvPr id="5" name="tracker"/>
           <p:cNvGrpSpPr/>
           <p:nvPr/>
         </p:nvGrpSpPr>
@@ -14271,7 +14191,7 @@
       </p:grpSp>
       <p:grpSp>
         <p:nvGrpSpPr>
-          <p:cNvPr id="7" name="Group 7"/>
+          <p:cNvPr id="7" name="title"/>
           <p:cNvGrpSpPr/>
           <p:nvPr/>
         </p:nvGrpSpPr>
@@ -14342,16 +14262,16 @@
       </p:grpSp>
       <p:grpSp>
         <p:nvGrpSpPr>
-          <p:cNvPr id="9" name="Group 9"/>
+          <p:cNvPr id="9" name="unit-line"/>
           <p:cNvGrpSpPr/>
           <p:nvPr/>
         </p:nvGrpSpPr>
         <p:grpSpPr>
           <a:xfrm>
             <a:off x="452438" y="1160145"/>
-            <a:ext cx="4355668" cy="176212"/>
+            <a:ext cx="4136555" cy="176212"/>
             <a:chOff x="452438" y="1160145"/>
-            <a:chExt cx="4355668" cy="176212"/>
+            <a:chExt cx="4136555" cy="176212"/>
           </a:xfrm>
         </p:grpSpPr>
         <p:sp>
@@ -14363,7 +14283,7 @@
           <p:spPr>
             <a:xfrm>
               <a:off x="452438" y="1160145"/>
-              <a:ext cx="4355668" cy="176212"/>
+              <a:ext cx="4136555" cy="176212"/>
             </a:xfrm>
             <a:prstGeom prst="rect">
               <a:avLst/>
@@ -14433,7 +14353,7 @@
       </p:sp>
       <p:grpSp>
         <p:nvGrpSpPr>
-          <p:cNvPr id="14" name="Group 14"/>
+          <p:cNvPr id="14" name="stage-2026"/>
           <p:cNvGrpSpPr/>
           <p:nvPr/>
         </p:nvGrpSpPr>
@@ -14478,7 +14398,7 @@
           <p:spPr>
             <a:xfrm>
               <a:off x="1442466" y="1629728"/>
-              <a:ext cx="337189" cy="205359"/>
+              <a:ext cx="325146" cy="205359"/>
             </a:xfrm>
             <a:prstGeom prst="rect">
               <a:avLst/>
@@ -14552,7 +14472,7 @@
       </p:grpSp>
       <p:grpSp>
         <p:nvGrpSpPr>
-          <p:cNvPr id="18" name="Group 18"/>
+          <p:cNvPr id="18" name="stage-2027"/>
           <p:cNvGrpSpPr/>
           <p:nvPr/>
         </p:nvGrpSpPr>
@@ -14597,7 +14517,7 @@
           <p:spPr>
             <a:xfrm>
               <a:off x="4947666" y="1629728"/>
-              <a:ext cx="337189" cy="205359"/>
+              <a:ext cx="325146" cy="205359"/>
             </a:xfrm>
             <a:prstGeom prst="rect">
               <a:avLst/>
@@ -14671,7 +14591,7 @@
       </p:grpSp>
       <p:grpSp>
         <p:nvGrpSpPr>
-          <p:cNvPr id="22" name="Group 22"/>
+          <p:cNvPr id="22" name="stage-2028"/>
           <p:cNvGrpSpPr/>
           <p:nvPr/>
         </p:nvGrpSpPr>
@@ -14716,7 +14636,7 @@
           <p:spPr>
             <a:xfrm>
               <a:off x="8452866" y="1629728"/>
-              <a:ext cx="337189" cy="205359"/>
+              <a:ext cx="325146" cy="205359"/>
             </a:xfrm>
             <a:prstGeom prst="rect">
               <a:avLst/>
@@ -14790,7 +14710,7 @@
       </p:grpSp>
       <p:grpSp>
         <p:nvGrpSpPr>
-          <p:cNvPr id="27" name="Group 27"/>
+          <p:cNvPr id="27" name="stage-outputs"/>
           <p:cNvGrpSpPr/>
           <p:nvPr/>
         </p:nvGrpSpPr>
@@ -14891,7 +14811,7 @@
           <p:spPr>
             <a:xfrm>
               <a:off x="4872038" y="2055495"/>
-              <a:ext cx="2928290" cy="176212"/>
+              <a:ext cx="2791130" cy="176212"/>
             </a:xfrm>
             <a:prstGeom prst="rect">
               <a:avLst/>
@@ -14965,7 +14885,7 @@
       </p:grpSp>
       <p:grpSp>
         <p:nvGrpSpPr>
-          <p:cNvPr id="33" name="Group 33"/>
+          <p:cNvPr id="33" name="lane-1"/>
           <p:cNvGrpSpPr/>
           <p:nvPr/>
         </p:nvGrpSpPr>
@@ -15288,7 +15208,7 @@
       </p:grpSp>
       <p:grpSp>
         <p:nvGrpSpPr>
-          <p:cNvPr id="38" name="Group 38"/>
+          <p:cNvPr id="38" name="lane-2"/>
           <p:cNvGrpSpPr/>
           <p:nvPr/>
         </p:nvGrpSpPr>
@@ -15565,7 +15485,7 @@
       </p:grpSp>
       <p:grpSp>
         <p:nvGrpSpPr>
-          <p:cNvPr id="44" name="Group 44"/>
+          <p:cNvPr id="44" name="lane-3"/>
           <p:cNvGrpSpPr/>
           <p:nvPr/>
         </p:nvGrpSpPr>
@@ -15864,7 +15784,7 @@
       </p:grpSp>
       <p:grpSp>
         <p:nvGrpSpPr>
-          <p:cNvPr id="48" name="Group 48"/>
+          <p:cNvPr id="48" name="decision-gate"/>
           <p:cNvGrpSpPr/>
           <p:nvPr/>
         </p:nvGrpSpPr>
@@ -15907,7 +15827,7 @@
           <p:spPr>
             <a:xfrm>
               <a:off x="604838" y="5503545"/>
-              <a:ext cx="2264847" cy="176212"/>
+              <a:ext cx="2158428" cy="176212"/>
             </a:xfrm>
             <a:prstGeom prst="rect">
               <a:avLst/>
@@ -15997,7 +15917,7 @@
       </p:grpSp>
       <p:grpSp>
         <p:nvGrpSpPr>
-          <p:cNvPr id="52" name="Group 52"/>
+          <p:cNvPr id="52" name="footer"/>
           <p:cNvGrpSpPr/>
           <p:nvPr/>
         </p:nvGrpSpPr>
@@ -16058,7 +15978,7 @@
           <p:spPr>
             <a:xfrm>
               <a:off x="452438" y="6357938"/>
-              <a:ext cx="5731497" cy="147638"/>
+              <a:ext cx="5691664" cy="147638"/>
             </a:xfrm>
             <a:prstGeom prst="rect">
               <a:avLst/>
@@ -16097,8 +16017,8 @@
           </p:nvSpPr>
           <p:spPr>
             <a:xfrm>
-              <a:off x="11618976" y="6357938"/>
-              <a:ext cx="120586" cy="147638"/>
+              <a:off x="11617724" y="6357938"/>
+              <a:ext cx="121838" cy="147638"/>
             </a:xfrm>
             <a:prstGeom prst="rect">
               <a:avLst/>
@@ -16606,16 +16526,16 @@
       </p:grpSpPr>
       <p:grpSp>
         <p:nvGrpSpPr>
-          <p:cNvPr id="5" name="Group 5"/>
+          <p:cNvPr id="5" name="tracker"/>
           <p:cNvGrpSpPr/>
           <p:nvPr/>
         </p:nvGrpSpPr>
         <p:grpSpPr>
           <a:xfrm>
-            <a:off x="10167508" y="247650"/>
-            <a:ext cx="1567292" cy="206216"/>
-            <a:chOff x="10167508" y="247650"/>
-            <a:chExt cx="1567292" cy="206216"/>
+            <a:off x="10168651" y="247650"/>
+            <a:ext cx="1566149" cy="206216"/>
+            <a:chOff x="10168651" y="247650"/>
+            <a:chExt cx="1566149" cy="206216"/>
           </a:xfrm>
         </p:grpSpPr>
         <p:sp>
@@ -16626,8 +16546,8 @@
           </p:nvSpPr>
           <p:spPr>
             <a:xfrm>
-              <a:off x="10167508" y="291941"/>
-              <a:ext cx="638604" cy="161925"/>
+              <a:off x="10168651" y="291941"/>
+              <a:ext cx="637461" cy="161925"/>
             </a:xfrm>
             <a:prstGeom prst="rect">
               <a:avLst/>
@@ -16723,7 +16643,7 @@
       </p:grpSp>
       <p:grpSp>
         <p:nvGrpSpPr>
-          <p:cNvPr id="7" name="Group 7"/>
+          <p:cNvPr id="7" name="title"/>
           <p:cNvGrpSpPr/>
           <p:nvPr/>
         </p:nvGrpSpPr>
@@ -16794,7 +16714,7 @@
       </p:grpSp>
       <p:grpSp>
         <p:nvGrpSpPr>
-          <p:cNvPr id="9" name="Group 9"/>
+          <p:cNvPr id="9" name="unit-line"/>
           <p:cNvGrpSpPr/>
           <p:nvPr/>
         </p:nvGrpSpPr>
@@ -17895,7 +17815,7 @@
       </p:graphicFrame>
       <p:grpSp>
         <p:nvGrpSpPr>
-          <p:cNvPr id="26" name="Group 26"/>
+          <p:cNvPr id="26" name="insights"/>
           <p:cNvGrpSpPr/>
           <p:nvPr/>
         </p:nvGrpSpPr>
@@ -18013,8 +17933,8 @@
           </p:nvSpPr>
           <p:spPr>
             <a:xfrm>
-              <a:off x="10062584" y="1905000"/>
-              <a:ext cx="67832" cy="147638"/>
+              <a:off x="10063659" y="1905000"/>
+              <a:ext cx="65682" cy="147638"/>
             </a:xfrm>
             <a:prstGeom prst="rect">
               <a:avLst/>
@@ -18143,8 +18063,8 @@
           </p:nvSpPr>
           <p:spPr>
             <a:xfrm>
-              <a:off x="10062584" y="2628900"/>
-              <a:ext cx="67832" cy="147638"/>
+              <a:off x="10063659" y="2628900"/>
+              <a:ext cx="65682" cy="147638"/>
             </a:xfrm>
             <a:prstGeom prst="rect">
               <a:avLst/>
@@ -18273,8 +18193,8 @@
           </p:nvSpPr>
           <p:spPr>
             <a:xfrm>
-              <a:off x="10062584" y="3352800"/>
-              <a:ext cx="67832" cy="147638"/>
+              <a:off x="10063659" y="3352800"/>
+              <a:ext cx="65682" cy="147638"/>
             </a:xfrm>
             <a:prstGeom prst="rect">
               <a:avLst/>
@@ -18403,8 +18323,8 @@
           </p:nvSpPr>
           <p:spPr>
             <a:xfrm>
-              <a:off x="10062584" y="4076700"/>
-              <a:ext cx="67832" cy="147638"/>
+              <a:off x="10063659" y="4076700"/>
+              <a:ext cx="65682" cy="147638"/>
             </a:xfrm>
             <a:prstGeom prst="rect">
               <a:avLst/>
@@ -18661,7 +18581,7 @@
       </p:grpSp>
       <p:grpSp>
         <p:nvGrpSpPr>
-          <p:cNvPr id="42" name="Group 42"/>
+          <p:cNvPr id="42" name="volatility-reference"/>
           <p:cNvGrpSpPr/>
           <p:nvPr/>
         </p:nvGrpSpPr>
@@ -18682,7 +18602,7 @@
           <p:spPr>
             <a:xfrm>
               <a:off x="452438" y="5568791"/>
-              <a:ext cx="1854775" cy="161925"/>
+              <a:ext cx="1851346" cy="161925"/>
             </a:xfrm>
             <a:prstGeom prst="rect">
               <a:avLst/>
@@ -18758,7 +18678,7 @@
           <p:spPr>
             <a:xfrm>
               <a:off x="448818" y="5784532"/>
-              <a:ext cx="529868" cy="322707"/>
+              <a:ext cx="479668" cy="322707"/>
             </a:xfrm>
             <a:prstGeom prst="rect">
               <a:avLst/>
@@ -18776,7 +18696,7 @@
             <a:p>
               <a:pPr algn="l"/>
               <a:r>
-                <a:rPr lang="zh-CN" sz="1650" b="1" dirty="0">
+                <a:rPr lang="en-US" sz="1650" b="1" dirty="0">
                   <a:solidFill>
                     <a:srgbClr val="B3261E"/>
                   </a:solidFill>
@@ -18838,7 +18758,7 @@
           <p:spPr>
             <a:xfrm>
               <a:off x="2763393" y="5784532"/>
-              <a:ext cx="658144" cy="322707"/>
+              <a:ext cx="603213" cy="322707"/>
             </a:xfrm>
             <a:prstGeom prst="rect">
               <a:avLst/>
@@ -18856,7 +18776,7 @@
             <a:p>
               <a:pPr algn="l"/>
               <a:r>
-                <a:rPr lang="zh-CN" sz="1650" b="1" dirty="0">
+                <a:rPr lang="en-US" sz="1650" b="1" dirty="0">
                   <a:solidFill>
                     <a:schemeClr val="accent2"/>
                   </a:solidFill>
@@ -18918,7 +18838,7 @@
           <p:spPr>
             <a:xfrm>
               <a:off x="5077968" y="5784532"/>
-              <a:ext cx="658144" cy="322707"/>
+              <a:ext cx="603213" cy="322707"/>
             </a:xfrm>
             <a:prstGeom prst="rect">
               <a:avLst/>
@@ -18936,7 +18856,7 @@
             <a:p>
               <a:pPr algn="l"/>
               <a:r>
-                <a:rPr lang="zh-CN" sz="1650" b="1" dirty="0">
+                <a:rPr lang="en-US" sz="1650" b="1" dirty="0">
                   <a:solidFill>
                     <a:schemeClr val="accent1"/>
                   </a:solidFill>
@@ -18958,7 +18878,7 @@
           <p:spPr>
             <a:xfrm>
               <a:off x="5081588" y="6025991"/>
-              <a:ext cx="1817395" cy="161925"/>
+              <a:ext cx="1738041" cy="161925"/>
             </a:xfrm>
             <a:prstGeom prst="rect">
               <a:avLst/>
@@ -18998,7 +18918,7 @@
           <p:spPr>
             <a:xfrm>
               <a:off x="7392543" y="5784532"/>
-              <a:ext cx="658144" cy="322707"/>
+              <a:ext cx="603213" cy="322707"/>
             </a:xfrm>
             <a:prstGeom prst="rect">
               <a:avLst/>
@@ -19016,7 +18936,7 @@
             <a:p>
               <a:pPr algn="l"/>
               <a:r>
-                <a:rPr lang="zh-CN" sz="1650" b="1" dirty="0">
+                <a:rPr lang="en-US" sz="1650" b="1" dirty="0">
                   <a:solidFill>
                     <a:schemeClr val="accent1"/>
                   </a:solidFill>
@@ -19072,7 +18992,7 @@
       </p:grpSp>
       <p:grpSp>
         <p:nvGrpSpPr>
-          <p:cNvPr id="47" name="Group 47"/>
+          <p:cNvPr id="47" name="footer"/>
           <p:cNvGrpSpPr/>
           <p:nvPr/>
         </p:nvGrpSpPr>
@@ -19093,7 +19013,7 @@
           <p:spPr>
             <a:xfrm>
               <a:off x="452438" y="6205538"/>
-              <a:ext cx="4244721" cy="147638"/>
+              <a:ext cx="4060412" cy="147638"/>
             </a:xfrm>
             <a:prstGeom prst="rect">
               <a:avLst/>
@@ -19133,7 +19053,7 @@
           <p:spPr>
             <a:xfrm>
               <a:off x="452438" y="6338888"/>
-              <a:ext cx="5183505" cy="147638"/>
+              <a:ext cx="4922330" cy="147638"/>
             </a:xfrm>
             <a:prstGeom prst="rect">
               <a:avLst/>
@@ -19173,7 +19093,7 @@
           <p:spPr>
             <a:xfrm>
               <a:off x="452438" y="6491288"/>
-              <a:ext cx="5731497" cy="147638"/>
+              <a:ext cx="5691664" cy="147638"/>
             </a:xfrm>
             <a:prstGeom prst="rect">
               <a:avLst/>
@@ -19212,8 +19132,8 @@
           </p:nvSpPr>
           <p:spPr>
             <a:xfrm>
-              <a:off x="11618976" y="6491288"/>
-              <a:ext cx="120586" cy="147638"/>
+              <a:off x="11617724" y="6491288"/>
+              <a:ext cx="121838" cy="147638"/>
             </a:xfrm>
             <a:prstGeom prst="rect">
               <a:avLst/>
@@ -19545,7 +19465,7 @@
       </p:grpSpPr>
       <p:grpSp>
         <p:nvGrpSpPr>
-          <p:cNvPr id="5" name="Group 5"/>
+          <p:cNvPr id="5" name="tracker"/>
           <p:cNvGrpSpPr/>
           <p:nvPr/>
         </p:nvGrpSpPr>
@@ -19662,7 +19582,7 @@
       </p:grpSp>
       <p:grpSp>
         <p:nvGrpSpPr>
-          <p:cNvPr id="7" name="Group 7"/>
+          <p:cNvPr id="7" name="title"/>
           <p:cNvGrpSpPr/>
           <p:nvPr/>
         </p:nvGrpSpPr>
@@ -19733,16 +19653,16 @@
       </p:grpSp>
       <p:grpSp>
         <p:nvGrpSpPr>
-          <p:cNvPr id="9" name="Group 9"/>
+          <p:cNvPr id="9" name="unit-line"/>
           <p:cNvGrpSpPr/>
           <p:nvPr/>
         </p:nvGrpSpPr>
         <p:grpSpPr>
           <a:xfrm>
             <a:off x="452438" y="1160145"/>
-            <a:ext cx="3432239" cy="176212"/>
+            <a:ext cx="3432238" cy="176212"/>
             <a:chOff x="452438" y="1160145"/>
-            <a:chExt cx="3432239" cy="176212"/>
+            <a:chExt cx="3432238" cy="176212"/>
           </a:xfrm>
         </p:grpSpPr>
         <p:sp>
@@ -19754,7 +19674,7 @@
           <p:spPr>
             <a:xfrm>
               <a:off x="452438" y="1160145"/>
-              <a:ext cx="3432239" cy="176212"/>
+              <a:ext cx="3432238" cy="176212"/>
             </a:xfrm>
             <a:prstGeom prst="rect">
               <a:avLst/>
@@ -19824,7 +19744,7 @@
       </p:sp>
       <p:grpSp>
         <p:nvGrpSpPr>
-          <p:cNvPr id="16" name="Group 16"/>
+          <p:cNvPr id="16" name="decision-header"/>
           <p:cNvGrpSpPr/>
           <p:nvPr/>
         </p:nvGrpSpPr>
@@ -19885,7 +19805,7 @@
           <p:spPr>
             <a:xfrm>
               <a:off x="4186238" y="1587341"/>
-              <a:ext cx="1191354" cy="161925"/>
+              <a:ext cx="1190211" cy="161925"/>
             </a:xfrm>
             <a:prstGeom prst="rect">
               <a:avLst/>
@@ -20035,7 +19955,7 @@
       </p:grpSp>
       <p:grpSp>
         <p:nvGrpSpPr>
-          <p:cNvPr id="24" name="Group 24"/>
+          <p:cNvPr id="24" name="decision-1"/>
           <p:cNvGrpSpPr/>
           <p:nvPr/>
         </p:nvGrpSpPr>
@@ -20056,7 +19976,7 @@
           <p:spPr>
             <a:xfrm>
               <a:off x="441960" y="1847850"/>
-              <a:ext cx="263709" cy="586740"/>
+              <a:ext cx="255107" cy="586740"/>
             </a:xfrm>
             <a:prstGeom prst="rect">
               <a:avLst/>
@@ -20374,7 +20294,7 @@
       </p:grpSp>
       <p:grpSp>
         <p:nvGrpSpPr>
-          <p:cNvPr id="32" name="Group 32"/>
+          <p:cNvPr id="32" name="decision-2"/>
           <p:cNvGrpSpPr/>
           <p:nvPr/>
         </p:nvGrpSpPr>
@@ -20395,7 +20315,7 @@
           <p:spPr>
             <a:xfrm>
               <a:off x="441960" y="2990850"/>
-              <a:ext cx="263709" cy="586740"/>
+              <a:ext cx="255107" cy="586740"/>
             </a:xfrm>
             <a:prstGeom prst="rect">
               <a:avLst/>
@@ -20435,7 +20355,7 @@
           <p:spPr>
             <a:xfrm>
               <a:off x="832485" y="3059906"/>
-              <a:ext cx="1913577" cy="220028"/>
+              <a:ext cx="1836767" cy="220028"/>
             </a:xfrm>
             <a:prstGeom prst="rect">
               <a:avLst/>
@@ -20713,7 +20633,7 @@
       </p:grpSp>
       <p:grpSp>
         <p:nvGrpSpPr>
-          <p:cNvPr id="40" name="Group 40"/>
+          <p:cNvPr id="40" name="decision-3"/>
           <p:cNvGrpSpPr/>
           <p:nvPr/>
         </p:nvGrpSpPr>
@@ -20734,7 +20654,7 @@
           <p:spPr>
             <a:xfrm>
               <a:off x="441960" y="4133850"/>
-              <a:ext cx="263709" cy="586740"/>
+              <a:ext cx="255107" cy="586740"/>
             </a:xfrm>
             <a:prstGeom prst="rect">
               <a:avLst/>
@@ -21052,7 +20972,7 @@
       </p:grpSp>
       <p:grpSp>
         <p:nvGrpSpPr>
-          <p:cNvPr id="46" name="Group 46"/>
+          <p:cNvPr id="46" name="milestones"/>
           <p:cNvGrpSpPr/>
           <p:nvPr/>
         </p:nvGrpSpPr>
@@ -21073,7 +20993,7 @@
           <p:spPr>
             <a:xfrm>
               <a:off x="452438" y="5302091"/>
-              <a:ext cx="1181217" cy="161925"/>
+              <a:ext cx="1178931" cy="161925"/>
             </a:xfrm>
             <a:prstGeom prst="rect">
               <a:avLst/>
@@ -21149,7 +21069,7 @@
           <p:spPr>
             <a:xfrm>
               <a:off x="448818" y="5536882"/>
-              <a:ext cx="3394009" cy="322707"/>
+              <a:ext cx="3419497" cy="322707"/>
             </a:xfrm>
             <a:prstGeom prst="rect">
               <a:avLst/>
@@ -21167,7 +21087,7 @@
             <a:p>
               <a:pPr algn="l"/>
               <a:r>
-                <a:rPr lang="zh-CN" sz="1650" b="1" dirty="0">
+                <a:rPr lang="en-US" sz="1650" b="1" dirty="0">
                   <a:solidFill>
                     <a:schemeClr val="accent2"/>
                   </a:solidFill>
@@ -21200,7 +21120,7 @@
           <p:spPr>
             <a:xfrm>
               <a:off x="4258818" y="5536882"/>
-              <a:ext cx="3522482" cy="322707"/>
+              <a:ext cx="3408410" cy="322707"/>
             </a:xfrm>
             <a:prstGeom prst="rect">
               <a:avLst/>
@@ -21218,7 +21138,7 @@
             <a:p>
               <a:pPr algn="l"/>
               <a:r>
-                <a:rPr lang="zh-CN" sz="1650" b="1" dirty="0">
+                <a:rPr lang="en-US" sz="1650" b="1" dirty="0">
                   <a:solidFill>
                     <a:schemeClr val="accent2"/>
                   </a:solidFill>
@@ -21251,7 +21171,7 @@
           <p:spPr>
             <a:xfrm>
               <a:off x="8068818" y="5536882"/>
-              <a:ext cx="2721582" cy="322707"/>
+              <a:ext cx="2747070" cy="322707"/>
             </a:xfrm>
             <a:prstGeom prst="rect">
               <a:avLst/>
@@ -21269,7 +21189,7 @@
             <a:p>
               <a:pPr algn="l"/>
               <a:r>
-                <a:rPr lang="zh-CN" sz="1650" b="1" dirty="0">
+                <a:rPr lang="en-US" sz="1650" b="1" dirty="0">
                   <a:solidFill>
                     <a:schemeClr val="accent2"/>
                   </a:solidFill>
@@ -21361,7 +21281,7 @@
           <p:spPr>
             <a:xfrm>
               <a:off x="604838" y="5989320"/>
-              <a:ext cx="6659356" cy="176212"/>
+              <a:ext cx="6394637" cy="176212"/>
             </a:xfrm>
             <a:prstGeom prst="rect">
               <a:avLst/>
@@ -21406,7 +21326,7 @@
       </p:grpSp>
       <p:grpSp>
         <p:nvGrpSpPr>
-          <p:cNvPr id="54" name="Group 54"/>
+          <p:cNvPr id="54" name="footer"/>
           <p:cNvGrpSpPr/>
           <p:nvPr/>
         </p:nvGrpSpPr>
@@ -21467,7 +21387,7 @@
           <p:spPr>
             <a:xfrm>
               <a:off x="452438" y="6357938"/>
-              <a:ext cx="5731497" cy="147638"/>
+              <a:ext cx="5691664" cy="147638"/>
             </a:xfrm>
             <a:prstGeom prst="rect">
               <a:avLst/>
@@ -21506,8 +21426,8 @@
           </p:nvSpPr>
           <p:spPr>
             <a:xfrm>
-              <a:off x="11618976" y="6357938"/>
-              <a:ext cx="120586" cy="147638"/>
+              <a:off x="11617724" y="6357938"/>
+              <a:ext cx="121838" cy="147638"/>
             </a:xfrm>
             <a:prstGeom prst="rect">
               <a:avLst/>
@@ -21892,7 +21812,7 @@
       </p:grpSpPr>
       <p:grpSp>
         <p:nvGrpSpPr>
-          <p:cNvPr id="5" name="Group 5"/>
+          <p:cNvPr id="5" name="tracker"/>
           <p:cNvGrpSpPr/>
           <p:nvPr/>
         </p:nvGrpSpPr>
@@ -22009,7 +21929,7 @@
       </p:grpSp>
       <p:grpSp>
         <p:nvGrpSpPr>
-          <p:cNvPr id="7" name="Group 7"/>
+          <p:cNvPr id="7" name="title"/>
           <p:cNvGrpSpPr/>
           <p:nvPr/>
         </p:nvGrpSpPr>
@@ -22080,16 +22000,16 @@
       </p:grpSp>
       <p:grpSp>
         <p:nvGrpSpPr>
-          <p:cNvPr id="9" name="Group 9"/>
+          <p:cNvPr id="9" name="unit-line"/>
           <p:cNvGrpSpPr/>
           <p:nvPr/>
         </p:nvGrpSpPr>
         <p:grpSpPr>
           <a:xfrm>
             <a:off x="452438" y="1160145"/>
-            <a:ext cx="4957343" cy="176212"/>
+            <a:ext cx="4742002" cy="176212"/>
             <a:chOff x="452438" y="1160145"/>
-            <a:chExt cx="4957343" cy="176212"/>
+            <a:chExt cx="4742002" cy="176212"/>
           </a:xfrm>
         </p:grpSpPr>
         <p:sp>
@@ -22101,7 +22021,7 @@
           <p:spPr>
             <a:xfrm>
               <a:off x="452438" y="1160145"/>
-              <a:ext cx="4957343" cy="176212"/>
+              <a:ext cx="4742002" cy="176212"/>
             </a:xfrm>
             <a:prstGeom prst="rect">
               <a:avLst/>
@@ -22171,7 +22091,7 @@
       </p:sp>
       <p:grpSp>
         <p:nvGrpSpPr>
-          <p:cNvPr id="15" name="Group 15"/>
+          <p:cNvPr id="15" name="exhibit-a-head"/>
           <p:cNvGrpSpPr/>
           <p:nvPr/>
         </p:nvGrpSpPr>
@@ -22213,8 +22133,8 @@
           </p:nvSpPr>
           <p:spPr>
             <a:xfrm>
-              <a:off x="497834" y="1581150"/>
-              <a:ext cx="71133" cy="147638"/>
+              <a:off x="490115" y="1581150"/>
+              <a:ext cx="86569" cy="147638"/>
             </a:xfrm>
             <a:prstGeom prst="rect">
               <a:avLst/>
@@ -22232,7 +22152,7 @@
             <a:p>
               <a:pPr algn="ctr"/>
               <a:r>
-                <a:rPr lang="zh-CN" sz="750" b="1" dirty="0">
+                <a:rPr lang="en-US" sz="750" b="1" dirty="0">
                   <a:solidFill>
                     <a:srgbClr val="FFFFFF"/>
                   </a:solidFill>
@@ -26956,16 +26876,16 @@
       </p:graphicFrame>
       <p:grpSp>
         <p:nvGrpSpPr>
-          <p:cNvPr id="21" name="Group 21"/>
+          <p:cNvPr id="21" name="exhibit-b-head"/>
           <p:cNvGrpSpPr/>
           <p:nvPr/>
         </p:nvGrpSpPr>
         <p:grpSpPr>
           <a:xfrm>
             <a:off x="8072438" y="1552575"/>
-            <a:ext cx="1853674" cy="349091"/>
+            <a:ext cx="1781798" cy="349091"/>
             <a:chOff x="8072438" y="1552575"/>
-            <a:chExt cx="1853674" cy="349091"/>
+            <a:chExt cx="1781798" cy="349091"/>
           </a:xfrm>
         </p:grpSpPr>
         <p:sp>
@@ -26998,8 +26918,8 @@
           </p:nvSpPr>
           <p:spPr>
             <a:xfrm>
-              <a:off x="8117834" y="1581150"/>
-              <a:ext cx="71133" cy="147638"/>
+              <a:off x="8110115" y="1581150"/>
+              <a:ext cx="86569" cy="147638"/>
             </a:xfrm>
             <a:prstGeom prst="rect">
               <a:avLst/>
@@ -27017,7 +26937,7 @@
             <a:p>
               <a:pPr algn="ctr"/>
               <a:r>
-                <a:rPr lang="zh-CN" sz="750" b="1" dirty="0">
+                <a:rPr lang="en-US" sz="750" b="1" dirty="0">
                   <a:solidFill>
                     <a:srgbClr val="FFFFFF"/>
                   </a:solidFill>
@@ -27039,7 +26959,7 @@
           <p:spPr>
             <a:xfrm>
               <a:off x="8281797" y="1571149"/>
-              <a:ext cx="1644315" cy="190690"/>
+              <a:ext cx="1572439" cy="190690"/>
             </a:xfrm>
             <a:prstGeom prst="rect">
               <a:avLst/>
@@ -28256,7 +28176,7 @@
       </p:graphicFrame>
       <p:grpSp>
         <p:nvGrpSpPr>
-          <p:cNvPr id="26" name="Group 26"/>
+          <p:cNvPr id="26" name="method-notes"/>
           <p:cNvGrpSpPr/>
           <p:nvPr/>
         </p:nvGrpSpPr>
@@ -28415,7 +28335,7 @@
       </p:grpSp>
       <p:grpSp>
         <p:nvGrpSpPr>
-          <p:cNvPr id="30" name="Group 30"/>
+          <p:cNvPr id="30" name="source-links"/>
           <p:cNvGrpSpPr/>
           <p:nvPr/>
         </p:nvGrpSpPr>
@@ -28546,7 +28466,7 @@
               </a:r>
               <a:br/>
               <a:r>
-                <a:rPr lang="zh-CN" sz="900" u="sng" dirty="0">
+                <a:rPr lang="en-US" sz="900" u="sng" dirty="0">
                   <a:solidFill>
                     <a:schemeClr val="accent2"/>
                   </a:solidFill>
@@ -28574,7 +28494,7 @@
       </p:grpSp>
       <p:grpSp>
         <p:nvGrpSpPr>
-          <p:cNvPr id="35" name="Group 35"/>
+          <p:cNvPr id="35" name="footer"/>
           <p:cNvGrpSpPr/>
           <p:nvPr/>
         </p:nvGrpSpPr>
@@ -28595,7 +28515,7 @@
           <p:spPr>
             <a:xfrm>
               <a:off x="452438" y="6205538"/>
-              <a:ext cx="4980813" cy="147638"/>
+              <a:ext cx="4781931" cy="147638"/>
             </a:xfrm>
             <a:prstGeom prst="rect">
               <a:avLst/>
@@ -28635,7 +28555,7 @@
           <p:spPr>
             <a:xfrm>
               <a:off x="452438" y="6338888"/>
-              <a:ext cx="6267494" cy="147638"/>
+              <a:ext cx="6240129" cy="147638"/>
             </a:xfrm>
             <a:prstGeom prst="rect">
               <a:avLst/>
@@ -28675,7 +28595,7 @@
           <p:spPr>
             <a:xfrm>
               <a:off x="452438" y="6491288"/>
-              <a:ext cx="3949555" cy="147638"/>
+              <a:ext cx="3940846" cy="147638"/>
             </a:xfrm>
             <a:prstGeom prst="rect">
               <a:avLst/>
@@ -28714,8 +28634,8 @@
           </p:nvSpPr>
           <p:spPr>
             <a:xfrm>
-              <a:off x="11618976" y="6491288"/>
-              <a:ext cx="120586" cy="147638"/>
+              <a:off x="11617724" y="6491288"/>
+              <a:ext cx="121838" cy="147638"/>
             </a:xfrm>
             <a:prstGeom prst="rect">
               <a:avLst/>
@@ -29135,7 +29055,7 @@
       </p:grpSpPr>
       <p:grpSp>
         <p:nvGrpSpPr>
-          <p:cNvPr id="5" name="Group 5"/>
+          <p:cNvPr id="5" name="tracker"/>
           <p:cNvGrpSpPr/>
           <p:nvPr/>
         </p:nvGrpSpPr>
@@ -29252,7 +29172,7 @@
       </p:grpSp>
       <p:grpSp>
         <p:nvGrpSpPr>
-          <p:cNvPr id="7" name="Group 7"/>
+          <p:cNvPr id="7" name="title"/>
           <p:cNvGrpSpPr/>
           <p:nvPr/>
         </p:nvGrpSpPr>
@@ -29323,7 +29243,7 @@
       </p:grpSp>
       <p:grpSp>
         <p:nvGrpSpPr>
-          <p:cNvPr id="9" name="Group 9"/>
+          <p:cNvPr id="9" name="unit-line"/>
           <p:cNvGrpSpPr/>
           <p:nvPr/>
         </p:nvGrpSpPr>
@@ -29414,7 +29334,7 @@
       </p:sp>
       <p:grpSp>
         <p:nvGrpSpPr>
-          <p:cNvPr id="15" name="Group 15"/>
+          <p:cNvPr id="15" name="finding-1"/>
           <p:cNvGrpSpPr/>
           <p:nvPr/>
         </p:nvGrpSpPr>
@@ -29456,8 +29376,8 @@
           </p:nvSpPr>
           <p:spPr>
             <a:xfrm>
-              <a:off x="499484" y="1676400"/>
-              <a:ext cx="67832" cy="147638"/>
+              <a:off x="500559" y="1676400"/>
+              <a:ext cx="65682" cy="147638"/>
             </a:xfrm>
             <a:prstGeom prst="rect">
               <a:avLst/>
@@ -29587,7 +29507,7 @@
       </p:grpSp>
       <p:grpSp>
         <p:nvGrpSpPr>
-          <p:cNvPr id="20" name="Group 20"/>
+          <p:cNvPr id="20" name="finding-2"/>
           <p:cNvGrpSpPr/>
           <p:nvPr/>
         </p:nvGrpSpPr>
@@ -29629,8 +29549,8 @@
           </p:nvSpPr>
           <p:spPr>
             <a:xfrm>
-              <a:off x="499484" y="2667000"/>
-              <a:ext cx="67832" cy="147638"/>
+              <a:off x="500559" y="2667000"/>
+              <a:ext cx="65682" cy="147638"/>
             </a:xfrm>
             <a:prstGeom prst="rect">
               <a:avLst/>
@@ -29760,7 +29680,7 @@
       </p:grpSp>
       <p:grpSp>
         <p:nvGrpSpPr>
-          <p:cNvPr id="25" name="Group 25"/>
+          <p:cNvPr id="25" name="finding-3"/>
           <p:cNvGrpSpPr/>
           <p:nvPr/>
         </p:nvGrpSpPr>
@@ -29802,8 +29722,8 @@
           </p:nvSpPr>
           <p:spPr>
             <a:xfrm>
-              <a:off x="499484" y="3657600"/>
-              <a:ext cx="67832" cy="147638"/>
+              <a:off x="500559" y="3657600"/>
+              <a:ext cx="65682" cy="147638"/>
             </a:xfrm>
             <a:prstGeom prst="rect">
               <a:avLst/>
@@ -29933,7 +29853,7 @@
       </p:grpSp>
       <p:grpSp>
         <p:nvGrpSpPr>
-          <p:cNvPr id="30" name="Group 30"/>
+          <p:cNvPr id="30" name="inference"/>
           <p:cNvGrpSpPr/>
           <p:nvPr/>
         </p:nvGrpSpPr>
@@ -30088,7 +30008,7 @@
       </p:grpSp>
       <p:grpSp>
         <p:nvGrpSpPr>
-          <p:cNvPr id="41" name="Group 41"/>
+          <p:cNvPr id="41" name="data-basis"/>
           <p:cNvGrpSpPr/>
           <p:nvPr/>
         </p:nvGrpSpPr>
@@ -30185,7 +30105,7 @@
           <p:spPr>
             <a:xfrm>
               <a:off x="447294" y="5561648"/>
-              <a:ext cx="1056470" cy="381381"/>
+              <a:ext cx="955430" cy="381381"/>
             </a:xfrm>
             <a:prstGeom prst="rect">
               <a:avLst/>
@@ -30276,7 +30196,7 @@
           <p:spPr>
             <a:xfrm>
               <a:off x="2447544" y="5561648"/>
-              <a:ext cx="529736" cy="381381"/>
+              <a:ext cx="545250" cy="381381"/>
             </a:xfrm>
             <a:prstGeom prst="rect">
               <a:avLst/>
@@ -30356,7 +30276,7 @@
           <p:spPr>
             <a:xfrm>
               <a:off x="4447794" y="5561648"/>
-              <a:ext cx="904871" cy="381381"/>
+              <a:ext cx="889803" cy="381381"/>
             </a:xfrm>
             <a:prstGeom prst="rect">
               <a:avLst/>
@@ -30447,7 +30367,7 @@
           <p:spPr>
             <a:xfrm>
               <a:off x="6448044" y="5561648"/>
-              <a:ext cx="1056470" cy="381381"/>
+              <a:ext cx="955430" cy="381381"/>
             </a:xfrm>
             <a:prstGeom prst="rect">
               <a:avLst/>
@@ -30532,7 +30452,7 @@
       </p:grpSp>
       <p:grpSp>
         <p:nvGrpSpPr>
-          <p:cNvPr id="60" name="Group 60"/>
+          <p:cNvPr id="60" name="decision-ask"/>
           <p:cNvGrpSpPr/>
           <p:nvPr/>
         </p:nvGrpSpPr>
@@ -30672,8 +30592,8 @@
           </p:nvSpPr>
           <p:spPr>
             <a:xfrm>
-              <a:off x="8805284" y="2152650"/>
-              <a:ext cx="67832" cy="147638"/>
+              <a:off x="8806359" y="2152650"/>
+              <a:ext cx="65682" cy="147638"/>
             </a:xfrm>
             <a:prstGeom prst="rect">
               <a:avLst/>
@@ -30842,8 +30762,8 @@
           </p:nvSpPr>
           <p:spPr>
             <a:xfrm>
-              <a:off x="8805284" y="3257550"/>
-              <a:ext cx="67832" cy="147638"/>
+              <a:off x="8806359" y="3257550"/>
+              <a:ext cx="65682" cy="147638"/>
             </a:xfrm>
             <a:prstGeom prst="rect">
               <a:avLst/>
@@ -30883,7 +30803,7 @@
           <p:spPr>
             <a:xfrm>
               <a:off x="8986266" y="3239452"/>
-              <a:ext cx="1793931" cy="205359"/>
+              <a:ext cx="1721922" cy="205359"/>
             </a:xfrm>
             <a:prstGeom prst="rect">
               <a:avLst/>
@@ -31000,8 +30920,8 @@
           </p:nvSpPr>
           <p:spPr>
             <a:xfrm>
-              <a:off x="8805284" y="4191000"/>
-              <a:ext cx="67832" cy="147638"/>
+              <a:off x="8806359" y="4191000"/>
+              <a:ext cx="65682" cy="147638"/>
             </a:xfrm>
             <a:prstGeom prst="rect">
               <a:avLst/>
@@ -31277,7 +31197,7 @@
       </p:grpSp>
       <p:grpSp>
         <p:nvGrpSpPr>
-          <p:cNvPr id="64" name="Group 64"/>
+          <p:cNvPr id="64" name="footer"/>
           <p:cNvGrpSpPr/>
           <p:nvPr/>
         </p:nvGrpSpPr>
@@ -31298,7 +31218,7 @@
           <p:spPr>
             <a:xfrm>
               <a:off x="452438" y="6205538"/>
-              <a:ext cx="4244721" cy="147638"/>
+              <a:ext cx="4060412" cy="147638"/>
             </a:xfrm>
             <a:prstGeom prst="rect">
               <a:avLst/>
@@ -31338,7 +31258,7 @@
           <p:spPr>
             <a:xfrm>
               <a:off x="452438" y="6357938"/>
-              <a:ext cx="5731497" cy="147638"/>
+              <a:ext cx="5691664" cy="147638"/>
             </a:xfrm>
             <a:prstGeom prst="rect">
               <a:avLst/>
@@ -31377,8 +31297,8 @@
           </p:nvSpPr>
           <p:spPr>
             <a:xfrm>
-              <a:off x="11674507" y="6357938"/>
-              <a:ext cx="65056" cy="147638"/>
+              <a:off x="11673881" y="6357938"/>
+              <a:ext cx="65682" cy="147638"/>
             </a:xfrm>
             <a:prstGeom prst="rect">
               <a:avLst/>
@@ -31798,7 +31718,7 @@
       </p:grpSpPr>
       <p:grpSp>
         <p:nvGrpSpPr>
-          <p:cNvPr id="5" name="Group 5"/>
+          <p:cNvPr id="5" name="tracker"/>
           <p:cNvGrpSpPr/>
           <p:nvPr/>
         </p:nvGrpSpPr>
@@ -31915,7 +31835,7 @@
       </p:grpSp>
       <p:grpSp>
         <p:nvGrpSpPr>
-          <p:cNvPr id="7" name="Group 7"/>
+          <p:cNvPr id="7" name="title"/>
           <p:cNvGrpSpPr/>
           <p:nvPr/>
         </p:nvGrpSpPr>
@@ -31986,16 +31906,16 @@
       </p:grpSp>
       <p:grpSp>
         <p:nvGrpSpPr>
-          <p:cNvPr id="9" name="Group 9"/>
+          <p:cNvPr id="9" name="unit-line"/>
           <p:cNvGrpSpPr/>
           <p:nvPr/>
         </p:nvGrpSpPr>
         <p:grpSpPr>
           <a:xfrm>
             <a:off x="452438" y="1160145"/>
-            <a:ext cx="3350743" cy="176212"/>
+            <a:ext cx="3190608" cy="176212"/>
             <a:chOff x="452438" y="1160145"/>
-            <a:chExt cx="3350743" cy="176212"/>
+            <a:chExt cx="3190608" cy="176212"/>
           </a:xfrm>
         </p:grpSpPr>
         <p:sp>
@@ -32007,7 +31927,7 @@
           <p:spPr>
             <a:xfrm>
               <a:off x="452438" y="1160145"/>
-              <a:ext cx="3350743" cy="176212"/>
+              <a:ext cx="3190608" cy="176212"/>
             </a:xfrm>
             <a:prstGeom prst="rect">
               <a:avLst/>
@@ -32077,16 +31997,16 @@
       </p:sp>
       <p:grpSp>
         <p:nvGrpSpPr>
-          <p:cNvPr id="15" name="Group 15"/>
+          <p:cNvPr id="15" name="exhibit-a-head"/>
           <p:cNvGrpSpPr/>
           <p:nvPr/>
         </p:nvGrpSpPr>
         <p:grpSpPr>
           <a:xfrm>
             <a:off x="452438" y="1552575"/>
-            <a:ext cx="1648272" cy="349091"/>
+            <a:ext cx="1572979" cy="349091"/>
             <a:chOff x="452438" y="1552575"/>
-            <a:chExt cx="1648272" cy="349091"/>
+            <a:chExt cx="1572979" cy="349091"/>
           </a:xfrm>
         </p:grpSpPr>
         <p:sp>
@@ -32119,8 +32039,8 @@
           </p:nvSpPr>
           <p:spPr>
             <a:xfrm>
-              <a:off x="497834" y="1581150"/>
-              <a:ext cx="71133" cy="147638"/>
+              <a:off x="490115" y="1581150"/>
+              <a:ext cx="86569" cy="147638"/>
             </a:xfrm>
             <a:prstGeom prst="rect">
               <a:avLst/>
@@ -32138,7 +32058,7 @@
             <a:p>
               <a:pPr algn="ctr"/>
               <a:r>
-                <a:rPr lang="zh-CN" sz="750" b="1" dirty="0">
+                <a:rPr lang="en-US" sz="750" b="1" dirty="0">
                   <a:solidFill>
                     <a:srgbClr val="FFFFFF"/>
                   </a:solidFill>
@@ -32200,7 +32120,7 @@
           <p:spPr>
             <a:xfrm>
               <a:off x="452438" y="1739741"/>
-              <a:ext cx="1648272" cy="161925"/>
+              <a:ext cx="1572979" cy="161925"/>
             </a:xfrm>
             <a:prstGeom prst="rect">
               <a:avLst/>
@@ -32305,7 +32225,7 @@
       </p:grpSp>
       <p:grpSp>
         <p:nvGrpSpPr>
-          <p:cNvPr id="23" name="Group 23"/>
+          <p:cNvPr id="23" name="exhibit-b-head"/>
           <p:cNvGrpSpPr/>
           <p:nvPr/>
         </p:nvGrpSpPr>
@@ -32347,8 +32267,8 @@
           </p:nvSpPr>
           <p:spPr>
             <a:xfrm>
-              <a:off x="4574534" y="1581150"/>
-              <a:ext cx="71133" cy="147638"/>
+              <a:off x="4566815" y="1581150"/>
+              <a:ext cx="86569" cy="147638"/>
             </a:xfrm>
             <a:prstGeom prst="rect">
               <a:avLst/>
@@ -32366,7 +32286,7 @@
             <a:p>
               <a:pPr algn="ctr"/>
               <a:r>
-                <a:rPr lang="zh-CN" sz="750" b="1" dirty="0">
+                <a:rPr lang="en-US" sz="750" b="1" dirty="0">
                   <a:solidFill>
                     <a:srgbClr val="FFFFFF"/>
                   </a:solidFill>
@@ -32609,7 +32529,7 @@
       </p:grpSp>
       <p:grpSp>
         <p:nvGrpSpPr>
-          <p:cNvPr id="33" name="Group 33"/>
+          <p:cNvPr id="33" name="exhibit-c-head"/>
           <p:cNvGrpSpPr/>
           <p:nvPr/>
         </p:nvGrpSpPr>
@@ -32651,8 +32571,8 @@
           </p:nvSpPr>
           <p:spPr>
             <a:xfrm>
-              <a:off x="497834" y="4610100"/>
-              <a:ext cx="71133" cy="147638"/>
+              <a:off x="490115" y="4610100"/>
+              <a:ext cx="86569" cy="147638"/>
             </a:xfrm>
             <a:prstGeom prst="rect">
               <a:avLst/>
@@ -32670,7 +32590,7 @@
             <a:p>
               <a:pPr algn="ctr"/>
               <a:r>
-                <a:rPr lang="zh-CN" sz="750" b="1" dirty="0">
+                <a:rPr lang="en-US" sz="750" b="1" dirty="0">
                   <a:solidFill>
                     <a:srgbClr val="FFFFFF"/>
                   </a:solidFill>
@@ -33815,7 +33735,7 @@
       </p:graphicFrame>
       <p:grpSp>
         <p:nvGrpSpPr>
-          <p:cNvPr id="50" name="Group 50"/>
+          <p:cNvPr id="50" name="insights"/>
           <p:cNvGrpSpPr/>
           <p:nvPr/>
         </p:nvGrpSpPr>
@@ -33933,8 +33853,8 @@
           </p:nvSpPr>
           <p:spPr>
             <a:xfrm>
-              <a:off x="8767184" y="1905000"/>
-              <a:ext cx="67832" cy="147638"/>
+              <a:off x="8768259" y="1905000"/>
+              <a:ext cx="65682" cy="147638"/>
             </a:xfrm>
             <a:prstGeom prst="rect">
               <a:avLst/>
@@ -34063,8 +33983,8 @@
           </p:nvSpPr>
           <p:spPr>
             <a:xfrm>
-              <a:off x="8767184" y="2628900"/>
-              <a:ext cx="67832" cy="147638"/>
+              <a:off x="8768259" y="2628900"/>
+              <a:ext cx="65682" cy="147638"/>
             </a:xfrm>
             <a:prstGeom prst="rect">
               <a:avLst/>
@@ -34193,8 +34113,8 @@
           </p:nvSpPr>
           <p:spPr>
             <a:xfrm>
-              <a:off x="8767184" y="3352800"/>
-              <a:ext cx="67832" cy="147638"/>
+              <a:off x="8768259" y="3352800"/>
+              <a:ext cx="65682" cy="147638"/>
             </a:xfrm>
             <a:prstGeom prst="rect">
               <a:avLst/>
@@ -34448,7 +34368,7 @@
       </p:grpSp>
       <p:grpSp>
         <p:nvGrpSpPr>
-          <p:cNvPr id="55" name="Group 55"/>
+          <p:cNvPr id="55" name="footer"/>
           <p:cNvGrpSpPr/>
           <p:nvPr/>
         </p:nvGrpSpPr>
@@ -34469,7 +34389,7 @@
           <p:spPr>
             <a:xfrm>
               <a:off x="452438" y="6205538"/>
-              <a:ext cx="4244721" cy="147638"/>
+              <a:ext cx="4060412" cy="147638"/>
             </a:xfrm>
             <a:prstGeom prst="rect">
               <a:avLst/>
@@ -34509,7 +34429,7 @@
           <p:spPr>
             <a:xfrm>
               <a:off x="452438" y="6338888"/>
-              <a:ext cx="3657981" cy="147638"/>
+              <a:ext cx="3481388" cy="147638"/>
             </a:xfrm>
             <a:prstGeom prst="rect">
               <a:avLst/>
@@ -34549,7 +34469,7 @@
           <p:spPr>
             <a:xfrm>
               <a:off x="452438" y="6491288"/>
-              <a:ext cx="5731497" cy="147638"/>
+              <a:ext cx="5691664" cy="147638"/>
             </a:xfrm>
             <a:prstGeom prst="rect">
               <a:avLst/>
@@ -34588,8 +34508,8 @@
           </p:nvSpPr>
           <p:spPr>
             <a:xfrm>
-              <a:off x="11674507" y="6491288"/>
-              <a:ext cx="65056" cy="147638"/>
+              <a:off x="11673881" y="6491288"/>
+              <a:ext cx="65682" cy="147638"/>
             </a:xfrm>
             <a:prstGeom prst="rect">
               <a:avLst/>
@@ -35053,7 +34973,7 @@
       </p:grpSpPr>
       <p:grpSp>
         <p:nvGrpSpPr>
-          <p:cNvPr id="5" name="Group 5"/>
+          <p:cNvPr id="5" name="tracker"/>
           <p:cNvGrpSpPr/>
           <p:nvPr/>
         </p:nvGrpSpPr>
@@ -35170,7 +35090,7 @@
       </p:grpSp>
       <p:grpSp>
         <p:nvGrpSpPr>
-          <p:cNvPr id="7" name="Group 7"/>
+          <p:cNvPr id="7" name="title"/>
           <p:cNvGrpSpPr/>
           <p:nvPr/>
         </p:nvGrpSpPr>
@@ -35241,16 +35161,16 @@
       </p:grpSp>
       <p:grpSp>
         <p:nvGrpSpPr>
-          <p:cNvPr id="9" name="Group 9"/>
+          <p:cNvPr id="9" name="unit-line"/>
           <p:cNvGrpSpPr/>
           <p:nvPr/>
         </p:nvGrpSpPr>
         <p:grpSpPr>
           <a:xfrm>
             <a:off x="452438" y="1160145"/>
-            <a:ext cx="4342867" cy="176212"/>
+            <a:ext cx="4184447" cy="176212"/>
             <a:chOff x="452438" y="1160145"/>
-            <a:chExt cx="4342867" cy="176212"/>
+            <a:chExt cx="4184447" cy="176212"/>
           </a:xfrm>
         </p:grpSpPr>
         <p:sp>
@@ -35262,7 +35182,7 @@
           <p:spPr>
             <a:xfrm>
               <a:off x="452438" y="1160145"/>
-              <a:ext cx="4342867" cy="176212"/>
+              <a:ext cx="4184447" cy="176212"/>
             </a:xfrm>
             <a:prstGeom prst="rect">
               <a:avLst/>
@@ -35332,7 +35252,7 @@
       </p:sp>
       <p:grpSp>
         <p:nvGrpSpPr>
-          <p:cNvPr id="15" name="Group 15"/>
+          <p:cNvPr id="15" name="exhibit-a-head"/>
           <p:cNvGrpSpPr/>
           <p:nvPr/>
         </p:nvGrpSpPr>
@@ -35374,8 +35294,8 @@
           </p:nvSpPr>
           <p:spPr>
             <a:xfrm>
-              <a:off x="497834" y="1581150"/>
-              <a:ext cx="71133" cy="147638"/>
+              <a:off x="490115" y="1581150"/>
+              <a:ext cx="86569" cy="147638"/>
             </a:xfrm>
             <a:prstGeom prst="rect">
               <a:avLst/>
@@ -35393,7 +35313,7 @@
             <a:p>
               <a:pPr algn="ctr"/>
               <a:r>
-                <a:rPr lang="zh-CN" sz="750" b="1" dirty="0">
+                <a:rPr lang="en-US" sz="750" b="1" dirty="0">
                   <a:solidFill>
                     <a:srgbClr val="FFFFFF"/>
                   </a:solidFill>
@@ -35750,7 +35670,7 @@
       </p:grpSp>
       <p:grpSp>
         <p:nvGrpSpPr>
-          <p:cNvPr id="34" name="Group 34"/>
+          <p:cNvPr id="34" name="growth-multiples"/>
           <p:cNvGrpSpPr/>
           <p:nvPr/>
         </p:nvGrpSpPr>
@@ -35771,7 +35691,7 @@
           <p:spPr>
             <a:xfrm>
               <a:off x="452438" y="4673441"/>
-              <a:ext cx="1881732" cy="161925"/>
+              <a:ext cx="1877160" cy="161925"/>
             </a:xfrm>
             <a:prstGeom prst="rect">
               <a:avLst/>
@@ -35847,7 +35767,7 @@
           <p:spPr>
             <a:xfrm>
               <a:off x="448818" y="4889182"/>
-              <a:ext cx="658144" cy="322707"/>
+              <a:ext cx="578824" cy="322707"/>
             </a:xfrm>
             <a:prstGeom prst="rect">
               <a:avLst/>
@@ -35927,7 +35847,7 @@
           <p:spPr>
             <a:xfrm>
               <a:off x="1410843" y="4889182"/>
-              <a:ext cx="529868" cy="322707"/>
+              <a:ext cx="455279" cy="322707"/>
             </a:xfrm>
             <a:prstGeom prst="rect">
               <a:avLst/>
@@ -36007,7 +35927,7 @@
           <p:spPr>
             <a:xfrm>
               <a:off x="2372868" y="4889182"/>
-              <a:ext cx="529868" cy="322707"/>
+              <a:ext cx="455279" cy="322707"/>
             </a:xfrm>
             <a:prstGeom prst="rect">
               <a:avLst/>
@@ -36087,7 +36007,7 @@
           <p:spPr>
             <a:xfrm>
               <a:off x="3334893" y="4889182"/>
-              <a:ext cx="658144" cy="322707"/>
+              <a:ext cx="578824" cy="322707"/>
             </a:xfrm>
             <a:prstGeom prst="rect">
               <a:avLst/>
@@ -36161,7 +36081,7 @@
       </p:grpSp>
       <p:grpSp>
         <p:nvGrpSpPr>
-          <p:cNvPr id="36" name="Group 36"/>
+          <p:cNvPr id="36" name="mix-note"/>
           <p:cNvGrpSpPr/>
           <p:nvPr/>
         </p:nvGrpSpPr>
@@ -36244,7 +36164,7 @@
       </p:grpSp>
       <p:grpSp>
         <p:nvGrpSpPr>
-          <p:cNvPr id="41" name="Group 41"/>
+          <p:cNvPr id="41" name="exhibit-b-head"/>
           <p:cNvGrpSpPr/>
           <p:nvPr/>
         </p:nvGrpSpPr>
@@ -36286,8 +36206,8 @@
           </p:nvSpPr>
           <p:spPr>
             <a:xfrm>
-              <a:off x="4574534" y="1581150"/>
-              <a:ext cx="71133" cy="147638"/>
+              <a:off x="4566815" y="1581150"/>
+              <a:ext cx="86569" cy="147638"/>
             </a:xfrm>
             <a:prstGeom prst="rect">
               <a:avLst/>
@@ -36305,7 +36225,7 @@
             <a:p>
               <a:pPr algn="ctr"/>
               <a:r>
-                <a:rPr lang="zh-CN" sz="750" b="1" dirty="0">
+                <a:rPr lang="en-US" sz="750" b="1" dirty="0">
                   <a:solidFill>
                     <a:srgbClr val="FFFFFF"/>
                   </a:solidFill>
@@ -36419,7 +36339,7 @@
       </p:graphicFrame>
       <p:grpSp>
         <p:nvGrpSpPr>
-          <p:cNvPr id="61" name="Group 61"/>
+          <p:cNvPr id="61" name="share-2025"/>
           <p:cNvGrpSpPr/>
           <p:nvPr/>
         </p:nvGrpSpPr>
@@ -36711,8 +36631,8 @@
           </p:nvSpPr>
           <p:spPr>
             <a:xfrm>
-              <a:off x="6400667" y="4820602"/>
-              <a:ext cx="272167" cy="205359"/>
+              <a:off x="6379238" y="4820602"/>
+              <a:ext cx="293596" cy="205359"/>
             </a:xfrm>
             <a:prstGeom prst="rect">
               <a:avLst/>
@@ -36751,8 +36671,8 @@
           </p:nvSpPr>
           <p:spPr>
             <a:xfrm>
-              <a:off x="8102092" y="4820602"/>
-              <a:ext cx="285242" cy="205359"/>
+              <a:off x="8093738" y="4820602"/>
+              <a:ext cx="293596" cy="205359"/>
             </a:xfrm>
             <a:prstGeom prst="rect">
               <a:avLst/>
@@ -36831,8 +36751,8 @@
           </p:nvSpPr>
           <p:spPr>
             <a:xfrm>
-              <a:off x="6400667" y="5030152"/>
-              <a:ext cx="272167" cy="205359"/>
+              <a:off x="6379238" y="5030152"/>
+              <a:ext cx="293596" cy="205359"/>
             </a:xfrm>
             <a:prstGeom prst="rect">
               <a:avLst/>
@@ -36871,8 +36791,8 @@
           </p:nvSpPr>
           <p:spPr>
             <a:xfrm>
-              <a:off x="8115167" y="5030152"/>
-              <a:ext cx="272167" cy="205359"/>
+              <a:off x="8093738" y="5030152"/>
+              <a:ext cx="293596" cy="205359"/>
             </a:xfrm>
             <a:prstGeom prst="rect">
               <a:avLst/>
@@ -36951,8 +36871,8 @@
           </p:nvSpPr>
           <p:spPr>
             <a:xfrm>
-              <a:off x="6478410" y="5239702"/>
-              <a:ext cx="194424" cy="205359"/>
+              <a:off x="6457857" y="5239702"/>
+              <a:ext cx="214977" cy="205359"/>
             </a:xfrm>
             <a:prstGeom prst="rect">
               <a:avLst/>
@@ -36991,8 +36911,8 @@
           </p:nvSpPr>
           <p:spPr>
             <a:xfrm>
-              <a:off x="8102092" y="5239702"/>
-              <a:ext cx="285242" cy="205359"/>
+              <a:off x="8089808" y="5239702"/>
+              <a:ext cx="297526" cy="205359"/>
             </a:xfrm>
             <a:prstGeom prst="rect">
               <a:avLst/>
@@ -37071,8 +36991,8 @@
           </p:nvSpPr>
           <p:spPr>
             <a:xfrm>
-              <a:off x="6400667" y="5449252"/>
-              <a:ext cx="272167" cy="205359"/>
+              <a:off x="6379238" y="5449252"/>
+              <a:ext cx="293596" cy="205359"/>
             </a:xfrm>
             <a:prstGeom prst="rect">
               <a:avLst/>
@@ -37111,8 +37031,8 @@
           </p:nvSpPr>
           <p:spPr>
             <a:xfrm>
-              <a:off x="8102092" y="5449252"/>
-              <a:ext cx="285242" cy="205359"/>
+              <a:off x="8093738" y="5449252"/>
+              <a:ext cx="293596" cy="205359"/>
             </a:xfrm>
             <a:prstGeom prst="rect">
               <a:avLst/>
@@ -37146,7 +37066,7 @@
       </p:grpSp>
       <p:grpSp>
         <p:nvGrpSpPr>
-          <p:cNvPr id="80" name="Group 80"/>
+          <p:cNvPr id="80" name="insights"/>
           <p:cNvGrpSpPr/>
           <p:nvPr/>
         </p:nvGrpSpPr>
@@ -37264,8 +37184,8 @@
           </p:nvSpPr>
           <p:spPr>
             <a:xfrm>
-              <a:off x="8767184" y="1905000"/>
-              <a:ext cx="67832" cy="147638"/>
+              <a:off x="8768259" y="1905000"/>
+              <a:ext cx="65682" cy="147638"/>
             </a:xfrm>
             <a:prstGeom prst="rect">
               <a:avLst/>
@@ -37394,8 +37314,8 @@
           </p:nvSpPr>
           <p:spPr>
             <a:xfrm>
-              <a:off x="8767184" y="2628900"/>
-              <a:ext cx="67832" cy="147638"/>
+              <a:off x="8768259" y="2628900"/>
+              <a:ext cx="65682" cy="147638"/>
             </a:xfrm>
             <a:prstGeom prst="rect">
               <a:avLst/>
@@ -37524,8 +37444,8 @@
           </p:nvSpPr>
           <p:spPr>
             <a:xfrm>
-              <a:off x="8767184" y="3352800"/>
-              <a:ext cx="67832" cy="147638"/>
+              <a:off x="8768259" y="3352800"/>
+              <a:ext cx="65682" cy="147638"/>
             </a:xfrm>
             <a:prstGeom prst="rect">
               <a:avLst/>
@@ -37654,8 +37574,8 @@
           </p:nvSpPr>
           <p:spPr>
             <a:xfrm>
-              <a:off x="8767184" y="4076700"/>
-              <a:ext cx="67832" cy="147638"/>
+              <a:off x="8768259" y="4076700"/>
+              <a:ext cx="65682" cy="147638"/>
             </a:xfrm>
             <a:prstGeom prst="rect">
               <a:avLst/>
@@ -37909,7 +37829,7 @@
       </p:grpSp>
       <p:grpSp>
         <p:nvGrpSpPr>
-          <p:cNvPr id="85" name="Group 85"/>
+          <p:cNvPr id="85" name="footer"/>
           <p:cNvGrpSpPr/>
           <p:nvPr/>
         </p:nvGrpSpPr>
@@ -37930,7 +37850,7 @@
           <p:spPr>
             <a:xfrm>
               <a:off x="452438" y="6205538"/>
-              <a:ext cx="4244721" cy="147638"/>
+              <a:ext cx="4060412" cy="147638"/>
             </a:xfrm>
             <a:prstGeom prst="rect">
               <a:avLst/>
@@ -38010,7 +37930,7 @@
           <p:spPr>
             <a:xfrm>
               <a:off x="452438" y="6491288"/>
-              <a:ext cx="5731497" cy="147638"/>
+              <a:ext cx="5691664" cy="147638"/>
             </a:xfrm>
             <a:prstGeom prst="rect">
               <a:avLst/>
@@ -38049,8 +37969,8 @@
           </p:nvSpPr>
           <p:spPr>
             <a:xfrm>
-              <a:off x="11674507" y="6491288"/>
-              <a:ext cx="65056" cy="147638"/>
+              <a:off x="11673881" y="6491288"/>
+              <a:ext cx="65682" cy="147638"/>
             </a:xfrm>
             <a:prstGeom prst="rect">
               <a:avLst/>
@@ -38558,16 +38478,16 @@
       </p:grpSpPr>
       <p:grpSp>
         <p:nvGrpSpPr>
-          <p:cNvPr id="5" name="Group 5"/>
+          <p:cNvPr id="5" name="tracker"/>
           <p:cNvGrpSpPr/>
           <p:nvPr/>
         </p:nvGrpSpPr>
         <p:grpSpPr>
           <a:xfrm>
-            <a:off x="9926538" y="247650"/>
-            <a:ext cx="1808262" cy="206216"/>
-            <a:chOff x="9926538" y="247650"/>
-            <a:chExt cx="1808262" cy="206216"/>
+            <a:off x="9927681" y="247650"/>
+            <a:ext cx="1807119" cy="206216"/>
+            <a:chOff x="9927681" y="247650"/>
+            <a:chExt cx="1807119" cy="206216"/>
           </a:xfrm>
         </p:grpSpPr>
         <p:sp>
@@ -38578,8 +38498,8 @@
           </p:nvSpPr>
           <p:spPr>
             <a:xfrm>
-              <a:off x="9926538" y="291941"/>
-              <a:ext cx="879574" cy="161925"/>
+              <a:off x="9927681" y="291941"/>
+              <a:ext cx="878431" cy="161925"/>
             </a:xfrm>
             <a:prstGeom prst="rect">
               <a:avLst/>
@@ -38675,7 +38595,7 @@
       </p:grpSp>
       <p:grpSp>
         <p:nvGrpSpPr>
-          <p:cNvPr id="7" name="Group 7"/>
+          <p:cNvPr id="7" name="title"/>
           <p:cNvGrpSpPr/>
           <p:nvPr/>
         </p:nvGrpSpPr>
@@ -38746,16 +38666,16 @@
       </p:grpSp>
       <p:grpSp>
         <p:nvGrpSpPr>
-          <p:cNvPr id="9" name="Group 9"/>
+          <p:cNvPr id="9" name="unit-line"/>
           <p:cNvGrpSpPr/>
           <p:nvPr/>
         </p:nvGrpSpPr>
         <p:grpSpPr>
           <a:xfrm>
             <a:off x="452438" y="1160145"/>
-            <a:ext cx="3670783" cy="176212"/>
+            <a:ext cx="3540138" cy="176212"/>
             <a:chOff x="452438" y="1160145"/>
-            <a:chExt cx="3670783" cy="176212"/>
+            <a:chExt cx="3540138" cy="176212"/>
           </a:xfrm>
         </p:grpSpPr>
         <p:sp>
@@ -38767,7 +38687,7 @@
           <p:spPr>
             <a:xfrm>
               <a:off x="452438" y="1160145"/>
-              <a:ext cx="3670783" cy="176212"/>
+              <a:ext cx="3540138" cy="176212"/>
             </a:xfrm>
             <a:prstGeom prst="rect">
               <a:avLst/>
@@ -38837,7 +38757,7 @@
       </p:sp>
       <p:grpSp>
         <p:nvGrpSpPr>
-          <p:cNvPr id="15" name="Group 15"/>
+          <p:cNvPr id="15" name="exhibit-a-head"/>
           <p:cNvGrpSpPr/>
           <p:nvPr/>
         </p:nvGrpSpPr>
@@ -38879,8 +38799,8 @@
           </p:nvSpPr>
           <p:spPr>
             <a:xfrm>
-              <a:off x="497834" y="1581150"/>
-              <a:ext cx="71133" cy="147638"/>
+              <a:off x="490115" y="1581150"/>
+              <a:ext cx="86569" cy="147638"/>
             </a:xfrm>
             <a:prstGeom prst="rect">
               <a:avLst/>
@@ -38898,7 +38818,7 @@
             <a:p>
               <a:pPr algn="ctr"/>
               <a:r>
-                <a:rPr lang="zh-CN" sz="750" b="1" dirty="0">
+                <a:rPr lang="en-US" sz="750" b="1" dirty="0">
                   <a:solidFill>
                     <a:srgbClr val="FFFFFF"/>
                   </a:solidFill>
@@ -39179,7 +39099,7 @@
       </p:grpSp>
       <p:grpSp>
         <p:nvGrpSpPr>
-          <p:cNvPr id="26" name="Group 26"/>
+          <p:cNvPr id="26" name="exhibit-b-head"/>
           <p:cNvGrpSpPr/>
           <p:nvPr/>
         </p:nvGrpSpPr>
@@ -39221,8 +39141,8 @@
           </p:nvSpPr>
           <p:spPr>
             <a:xfrm>
-              <a:off x="4574534" y="1581150"/>
-              <a:ext cx="71133" cy="147638"/>
+              <a:off x="4566815" y="1581150"/>
+              <a:ext cx="86569" cy="147638"/>
             </a:xfrm>
             <a:prstGeom prst="rect">
               <a:avLst/>
@@ -39240,7 +39160,7 @@
             <a:p>
               <a:pPr algn="ctr"/>
               <a:r>
-                <a:rPr lang="zh-CN" sz="750" b="1" dirty="0">
+                <a:rPr lang="en-US" sz="750" b="1" dirty="0">
                   <a:solidFill>
                     <a:srgbClr val="FFFFFF"/>
                   </a:solidFill>
@@ -39354,7 +39274,7 @@
       </p:graphicFrame>
       <p:grpSp>
         <p:nvGrpSpPr>
-          <p:cNvPr id="32" name="Group 32"/>
+          <p:cNvPr id="32" name="exhibit-c-head"/>
           <p:cNvGrpSpPr/>
           <p:nvPr/>
         </p:nvGrpSpPr>
@@ -39396,8 +39316,8 @@
           </p:nvSpPr>
           <p:spPr>
             <a:xfrm>
-              <a:off x="497834" y="4610100"/>
-              <a:ext cx="71133" cy="147638"/>
+              <a:off x="490115" y="4610100"/>
+              <a:ext cx="86569" cy="147638"/>
             </a:xfrm>
             <a:prstGeom prst="rect">
               <a:avLst/>
@@ -39415,7 +39335,7 @@
             <a:p>
               <a:pPr algn="ctr"/>
               <a:r>
-                <a:rPr lang="zh-CN" sz="750" b="1" dirty="0">
+                <a:rPr lang="en-US" sz="750" b="1" dirty="0">
                   <a:solidFill>
                     <a:srgbClr val="FFFFFF"/>
                   </a:solidFill>
@@ -40678,8 +40598,8 @@
           </p:nvSpPr>
           <p:spPr>
             <a:xfrm>
-              <a:off x="8767184" y="1905000"/>
-              <a:ext cx="67832" cy="147638"/>
+              <a:off x="8768259" y="1905000"/>
+              <a:ext cx="65682" cy="147638"/>
             </a:xfrm>
             <a:prstGeom prst="rect">
               <a:avLst/>
@@ -40808,8 +40728,8 @@
           </p:nvSpPr>
           <p:spPr>
             <a:xfrm>
-              <a:off x="8767184" y="2628900"/>
-              <a:ext cx="67832" cy="147638"/>
+              <a:off x="8768259" y="2628900"/>
+              <a:ext cx="65682" cy="147638"/>
             </a:xfrm>
             <a:prstGeom prst="rect">
               <a:avLst/>
@@ -40926,8 +40846,8 @@
           </p:nvSpPr>
           <p:spPr>
             <a:xfrm>
-              <a:off x="8767184" y="3162300"/>
-              <a:ext cx="67832" cy="147638"/>
+              <a:off x="8768259" y="3162300"/>
+              <a:ext cx="65682" cy="147638"/>
             </a:xfrm>
             <a:prstGeom prst="rect">
               <a:avLst/>
@@ -41056,8 +40976,8 @@
           </p:nvSpPr>
           <p:spPr>
             <a:xfrm>
-              <a:off x="8767184" y="3886200"/>
-              <a:ext cx="67832" cy="147638"/>
+              <a:off x="8768259" y="3886200"/>
+              <a:ext cx="65682" cy="147638"/>
             </a:xfrm>
             <a:prstGeom prst="rect">
               <a:avLst/>
@@ -41311,7 +41231,7 @@
       </p:grpSp>
       <p:grpSp>
         <p:nvGrpSpPr>
-          <p:cNvPr id="57" name="Group 57"/>
+          <p:cNvPr id="57" name="footer"/>
           <p:cNvGrpSpPr/>
           <p:nvPr/>
         </p:nvGrpSpPr>
@@ -41332,7 +41252,7 @@
           <p:spPr>
             <a:xfrm>
               <a:off x="452438" y="6205538"/>
-              <a:ext cx="4244721" cy="147638"/>
+              <a:ext cx="4060412" cy="147638"/>
             </a:xfrm>
             <a:prstGeom prst="rect">
               <a:avLst/>
@@ -41412,7 +41332,7 @@
           <p:spPr>
             <a:xfrm>
               <a:off x="452438" y="6491288"/>
-              <a:ext cx="5731497" cy="147638"/>
+              <a:ext cx="5691664" cy="147638"/>
             </a:xfrm>
             <a:prstGeom prst="rect">
               <a:avLst/>
@@ -41451,8 +41371,8 @@
           </p:nvSpPr>
           <p:spPr>
             <a:xfrm>
-              <a:off x="11674507" y="6491288"/>
-              <a:ext cx="65056" cy="147638"/>
+              <a:off x="11673881" y="6491288"/>
+              <a:ext cx="65682" cy="147638"/>
             </a:xfrm>
             <a:prstGeom prst="rect">
               <a:avLst/>
@@ -41916,16 +41836,16 @@
       </p:grpSpPr>
       <p:grpSp>
         <p:nvGrpSpPr>
-          <p:cNvPr id="5" name="Group 5"/>
+          <p:cNvPr id="5" name="tracker"/>
           <p:cNvGrpSpPr/>
           <p:nvPr/>
         </p:nvGrpSpPr>
         <p:grpSpPr>
           <a:xfrm>
-            <a:off x="10167508" y="247650"/>
-            <a:ext cx="1567292" cy="206216"/>
-            <a:chOff x="10167508" y="247650"/>
-            <a:chExt cx="1567292" cy="206216"/>
+            <a:off x="10168651" y="247650"/>
+            <a:ext cx="1566149" cy="206216"/>
+            <a:chOff x="10168651" y="247650"/>
+            <a:chExt cx="1566149" cy="206216"/>
           </a:xfrm>
         </p:grpSpPr>
         <p:sp>
@@ -41936,8 +41856,8 @@
           </p:nvSpPr>
           <p:spPr>
             <a:xfrm>
-              <a:off x="10167508" y="291941"/>
-              <a:ext cx="638604" cy="161925"/>
+              <a:off x="10168651" y="291941"/>
+              <a:ext cx="637461" cy="161925"/>
             </a:xfrm>
             <a:prstGeom prst="rect">
               <a:avLst/>
@@ -42033,7 +41953,7 @@
       </p:grpSp>
       <p:grpSp>
         <p:nvGrpSpPr>
-          <p:cNvPr id="7" name="Group 7"/>
+          <p:cNvPr id="7" name="title"/>
           <p:cNvGrpSpPr/>
           <p:nvPr/>
         </p:nvGrpSpPr>
@@ -42104,16 +42024,16 @@
       </p:grpSp>
       <p:grpSp>
         <p:nvGrpSpPr>
-          <p:cNvPr id="9" name="Group 9"/>
+          <p:cNvPr id="9" name="unit-line"/>
           <p:cNvGrpSpPr/>
           <p:nvPr/>
         </p:nvGrpSpPr>
         <p:grpSpPr>
           <a:xfrm>
             <a:off x="452438" y="1160145"/>
-            <a:ext cx="5005464" cy="176212"/>
+            <a:ext cx="4903965" cy="176212"/>
             <a:chOff x="452438" y="1160145"/>
-            <a:chExt cx="5005464" cy="176212"/>
+            <a:chExt cx="4903965" cy="176212"/>
           </a:xfrm>
         </p:grpSpPr>
         <p:sp>
@@ -42125,7 +42045,7 @@
           <p:spPr>
             <a:xfrm>
               <a:off x="452438" y="1160145"/>
-              <a:ext cx="5005464" cy="176212"/>
+              <a:ext cx="4903965" cy="176212"/>
             </a:xfrm>
             <a:prstGeom prst="rect">
               <a:avLst/>
@@ -42195,7 +42115,7 @@
       </p:sp>
       <p:grpSp>
         <p:nvGrpSpPr>
-          <p:cNvPr id="15" name="Group 15"/>
+          <p:cNvPr id="15" name="exhibit-a-head"/>
           <p:cNvGrpSpPr/>
           <p:nvPr/>
         </p:nvGrpSpPr>
@@ -42237,8 +42157,8 @@
           </p:nvSpPr>
           <p:spPr>
             <a:xfrm>
-              <a:off x="497834" y="1581150"/>
-              <a:ext cx="71133" cy="147638"/>
+              <a:off x="490115" y="1581150"/>
+              <a:ext cx="86569" cy="147638"/>
             </a:xfrm>
             <a:prstGeom prst="rect">
               <a:avLst/>
@@ -42256,7 +42176,7 @@
             <a:p>
               <a:pPr algn="ctr"/>
               <a:r>
-                <a:rPr lang="zh-CN" sz="750" b="1" dirty="0">
+                <a:rPr lang="en-US" sz="750" b="1" dirty="0">
                   <a:solidFill>
                     <a:srgbClr val="FFFFFF"/>
                   </a:solidFill>
@@ -42407,7 +42327,7 @@
             <a:p>
               <a:pPr algn="l"/>
               <a:r>
-                <a:rPr lang="zh-CN" sz="820">
+                <a:rPr lang="en-US" sz="820">
                   <a:solidFill>
                     <a:srgbClr val="7F7F7F"/>
                   </a:solidFill>
@@ -42445,7 +42365,7 @@
             <a:p>
               <a:pPr algn="l"/>
               <a:r>
-                <a:rPr lang="zh-CN" sz="820">
+                <a:rPr lang="en-US" sz="820">
                   <a:solidFill>
                     <a:srgbClr val="2251FF"/>
                   </a:solidFill>
@@ -42483,7 +42403,7 @@
             <a:p>
               <a:pPr algn="l"/>
               <a:r>
-                <a:rPr lang="zh-CN" sz="820">
+                <a:rPr lang="en-US" sz="820">
                   <a:solidFill>
                     <a:srgbClr val="2251FF"/>
                   </a:solidFill>
@@ -42521,7 +42441,7 @@
             <a:p>
               <a:pPr algn="l"/>
               <a:r>
-                <a:rPr lang="zh-CN" sz="820">
+                <a:rPr lang="en-US" sz="820">
                   <a:solidFill>
                     <a:srgbClr val="051C2C"/>
                   </a:solidFill>
@@ -42559,7 +42479,7 @@
             <a:p>
               <a:pPr algn="l"/>
               <a:r>
-                <a:rPr lang="zh-CN" sz="820">
+                <a:rPr lang="en-US" sz="820">
                   <a:solidFill>
                     <a:srgbClr val="7F7F7F"/>
                   </a:solidFill>
@@ -42575,7 +42495,7 @@
       </p:grpSp>
       <p:grpSp>
         <p:nvGrpSpPr>
-          <p:cNvPr id="27" name="Group 27"/>
+          <p:cNvPr id="27" name="exhibit-b-head"/>
           <p:cNvGrpSpPr/>
           <p:nvPr/>
         </p:nvGrpSpPr>
@@ -42617,8 +42537,8 @@
           </p:nvSpPr>
           <p:spPr>
             <a:xfrm>
-              <a:off x="4574534" y="1581150"/>
-              <a:ext cx="71133" cy="147638"/>
+              <a:off x="4566815" y="1581150"/>
+              <a:ext cx="86569" cy="147638"/>
             </a:xfrm>
             <a:prstGeom prst="rect">
               <a:avLst/>
@@ -42636,7 +42556,7 @@
             <a:p>
               <a:pPr algn="ctr"/>
               <a:r>
-                <a:rPr lang="zh-CN" sz="750" b="1" dirty="0">
+                <a:rPr lang="en-US" sz="750" b="1" dirty="0">
                   <a:solidFill>
                     <a:srgbClr val="FFFFFF"/>
                   </a:solidFill>
@@ -42750,7 +42670,7 @@
       </p:graphicFrame>
       <p:grpSp>
         <p:nvGrpSpPr>
-          <p:cNvPr id="33" name="Group 33"/>
+          <p:cNvPr id="33" name="exhibit-c-head"/>
           <p:cNvGrpSpPr/>
           <p:nvPr/>
         </p:nvGrpSpPr>
@@ -42792,8 +42712,8 @@
           </p:nvSpPr>
           <p:spPr>
             <a:xfrm>
-              <a:off x="497834" y="4610100"/>
-              <a:ext cx="71133" cy="147638"/>
+              <a:off x="490115" y="4610100"/>
+              <a:ext cx="86569" cy="147638"/>
             </a:xfrm>
             <a:prstGeom prst="rect">
               <a:avLst/>
@@ -42811,7 +42731,7 @@
             <a:p>
               <a:pPr algn="ctr"/>
               <a:r>
-                <a:rPr lang="zh-CN" sz="750" b="1" dirty="0">
+                <a:rPr lang="en-US" sz="750" b="1" dirty="0">
                   <a:solidFill>
                     <a:srgbClr val="FFFFFF"/>
                   </a:solidFill>
@@ -43333,7 +43253,7 @@
                     <a:p>
                       <a:pPr algn="r"/>
                       <a:r>
-                        <a:rPr lang="zh-CN" sz="820" b="0">
+                        <a:rPr lang="en-US" sz="820" b="0">
                           <a:solidFill>
                             <a:schemeClr val="dk1"/>
                           </a:solidFill>
@@ -43581,7 +43501,7 @@
                     <a:p>
                       <a:pPr algn="r"/>
                       <a:r>
-                        <a:rPr lang="zh-CN" sz="820" b="0">
+                        <a:rPr lang="en-US" sz="820" b="0">
                           <a:solidFill>
                             <a:schemeClr val="dk1"/>
                           </a:solidFill>
@@ -43829,7 +43749,7 @@
                     <a:p>
                       <a:pPr algn="r"/>
                       <a:r>
-                        <a:rPr lang="zh-CN" sz="820" b="0">
+                        <a:rPr lang="en-US" sz="820" b="0">
                           <a:solidFill>
                             <a:schemeClr val="dk1"/>
                           </a:solidFill>
@@ -44077,7 +43997,7 @@
                     <a:p>
                       <a:pPr algn="r"/>
                       <a:r>
-                        <a:rPr lang="zh-CN" sz="820" b="0">
+                        <a:rPr lang="en-US" sz="820" b="0">
                           <a:solidFill>
                             <a:schemeClr val="dk1"/>
                           </a:solidFill>
@@ -44277,8 +44197,8 @@
           </p:nvSpPr>
           <p:spPr>
             <a:xfrm>
-              <a:off x="8767184" y="1905000"/>
-              <a:ext cx="67832" cy="147638"/>
+              <a:off x="8768259" y="1905000"/>
+              <a:ext cx="65682" cy="147638"/>
             </a:xfrm>
             <a:prstGeom prst="rect">
               <a:avLst/>
@@ -44407,8 +44327,8 @@
           </p:nvSpPr>
           <p:spPr>
             <a:xfrm>
-              <a:off x="8767184" y="2628900"/>
-              <a:ext cx="67832" cy="147638"/>
+              <a:off x="8768259" y="2628900"/>
+              <a:ext cx="65682" cy="147638"/>
             </a:xfrm>
             <a:prstGeom prst="rect">
               <a:avLst/>
@@ -44537,8 +44457,8 @@
           </p:nvSpPr>
           <p:spPr>
             <a:xfrm>
-              <a:off x="8767184" y="3352800"/>
-              <a:ext cx="67832" cy="147638"/>
+              <a:off x="8768259" y="3352800"/>
+              <a:ext cx="65682" cy="147638"/>
             </a:xfrm>
             <a:prstGeom prst="rect">
               <a:avLst/>
@@ -44667,8 +44587,8 @@
           </p:nvSpPr>
           <p:spPr>
             <a:xfrm>
-              <a:off x="8767184" y="4076700"/>
-              <a:ext cx="67832" cy="147638"/>
+              <a:off x="8768259" y="4076700"/>
+              <a:ext cx="65682" cy="147638"/>
             </a:xfrm>
             <a:prstGeom prst="rect">
               <a:avLst/>
@@ -44922,7 +44842,7 @@
       </p:grpSp>
       <p:grpSp>
         <p:nvGrpSpPr>
-          <p:cNvPr id="58" name="Group 58"/>
+          <p:cNvPr id="58" name="footer"/>
           <p:cNvGrpSpPr/>
           <p:nvPr/>
         </p:nvGrpSpPr>
@@ -44943,7 +44863,7 @@
           <p:spPr>
             <a:xfrm>
               <a:off x="452438" y="6205538"/>
-              <a:ext cx="4244721" cy="147638"/>
+              <a:ext cx="4060412" cy="147638"/>
             </a:xfrm>
             <a:prstGeom prst="rect">
               <a:avLst/>
@@ -44983,7 +44903,7 @@
           <p:spPr>
             <a:xfrm>
               <a:off x="452438" y="6338888"/>
-              <a:ext cx="4244721" cy="147638"/>
+              <a:ext cx="4056412" cy="147638"/>
             </a:xfrm>
             <a:prstGeom prst="rect">
               <a:avLst/>
@@ -45023,7 +44943,7 @@
           <p:spPr>
             <a:xfrm>
               <a:off x="452438" y="6491288"/>
-              <a:ext cx="5731497" cy="147638"/>
+              <a:ext cx="5691664" cy="147638"/>
             </a:xfrm>
             <a:prstGeom prst="rect">
               <a:avLst/>
@@ -45062,8 +44982,8 @@
           </p:nvSpPr>
           <p:spPr>
             <a:xfrm>
-              <a:off x="11674507" y="6491288"/>
-              <a:ext cx="65056" cy="147638"/>
+              <a:off x="11673881" y="6491288"/>
+              <a:ext cx="65682" cy="147638"/>
             </a:xfrm>
             <a:prstGeom prst="rect">
               <a:avLst/>
@@ -45536,16 +45456,16 @@
       </p:grpSpPr>
       <p:grpSp>
         <p:nvGrpSpPr>
-          <p:cNvPr id="5" name="Group 5"/>
+          <p:cNvPr id="5" name="tracker"/>
           <p:cNvGrpSpPr/>
           <p:nvPr/>
         </p:nvGrpSpPr>
         <p:grpSpPr>
           <a:xfrm>
-            <a:off x="9926538" y="247650"/>
-            <a:ext cx="1808262" cy="206216"/>
-            <a:chOff x="9926538" y="247650"/>
-            <a:chExt cx="1808262" cy="206216"/>
+            <a:off x="9927681" y="247650"/>
+            <a:ext cx="1807119" cy="206216"/>
+            <a:chOff x="9927681" y="247650"/>
+            <a:chExt cx="1807119" cy="206216"/>
           </a:xfrm>
         </p:grpSpPr>
         <p:sp>
@@ -45556,8 +45476,8 @@
           </p:nvSpPr>
           <p:spPr>
             <a:xfrm>
-              <a:off x="9926538" y="291941"/>
-              <a:ext cx="879574" cy="161925"/>
+              <a:off x="9927681" y="291941"/>
+              <a:ext cx="878431" cy="161925"/>
             </a:xfrm>
             <a:prstGeom prst="rect">
               <a:avLst/>
@@ -45653,7 +45573,7 @@
       </p:grpSp>
       <p:grpSp>
         <p:nvGrpSpPr>
-          <p:cNvPr id="7" name="Group 7"/>
+          <p:cNvPr id="7" name="title"/>
           <p:cNvGrpSpPr/>
           <p:nvPr/>
         </p:nvGrpSpPr>
@@ -45724,16 +45644,16 @@
       </p:grpSp>
       <p:grpSp>
         <p:nvGrpSpPr>
-          <p:cNvPr id="9" name="Group 9"/>
+          <p:cNvPr id="9" name="unit-line"/>
           <p:cNvGrpSpPr/>
           <p:nvPr/>
         </p:nvGrpSpPr>
         <p:grpSpPr>
           <a:xfrm>
             <a:off x="452438" y="1160145"/>
-            <a:ext cx="4600556" cy="176212"/>
+            <a:ext cx="4509402" cy="176212"/>
             <a:chOff x="452438" y="1160145"/>
-            <a:chExt cx="4600556" cy="176212"/>
+            <a:chExt cx="4509402" cy="176212"/>
           </a:xfrm>
         </p:grpSpPr>
         <p:sp>
@@ -45745,7 +45665,7 @@
           <p:spPr>
             <a:xfrm>
               <a:off x="452438" y="1160145"/>
-              <a:ext cx="4600556" cy="176212"/>
+              <a:ext cx="4509402" cy="176212"/>
             </a:xfrm>
             <a:prstGeom prst="rect">
               <a:avLst/>
@@ -45815,7 +45735,7 @@
       </p:sp>
       <p:grpSp>
         <p:nvGrpSpPr>
-          <p:cNvPr id="15" name="Group 15"/>
+          <p:cNvPr id="15" name="exhibit-a-head"/>
           <p:cNvGrpSpPr/>
           <p:nvPr/>
         </p:nvGrpSpPr>
@@ -45857,8 +45777,8 @@
           </p:nvSpPr>
           <p:spPr>
             <a:xfrm>
-              <a:off x="497834" y="1581150"/>
-              <a:ext cx="71133" cy="147638"/>
+              <a:off x="490115" y="1581150"/>
+              <a:ext cx="86569" cy="147638"/>
             </a:xfrm>
             <a:prstGeom prst="rect">
               <a:avLst/>
@@ -45876,7 +45796,7 @@
             <a:p>
               <a:pPr algn="ctr"/>
               <a:r>
-                <a:rPr lang="zh-CN" sz="750" b="1" dirty="0">
+                <a:rPr lang="en-US" sz="750" b="1" dirty="0">
                   <a:solidFill>
                     <a:srgbClr val="FFFFFF"/>
                   </a:solidFill>
@@ -45990,7 +45910,7 @@
       </p:graphicFrame>
       <p:grpSp>
         <p:nvGrpSpPr>
-          <p:cNvPr id="21" name="Group 21"/>
+          <p:cNvPr id="21" name="exhibit-b-head"/>
           <p:cNvGrpSpPr/>
           <p:nvPr/>
         </p:nvGrpSpPr>
@@ -46032,8 +45952,8 @@
           </p:nvSpPr>
           <p:spPr>
             <a:xfrm>
-              <a:off x="4574534" y="1581150"/>
-              <a:ext cx="71133" cy="147638"/>
+              <a:off x="4566815" y="1581150"/>
+              <a:ext cx="86569" cy="147638"/>
             </a:xfrm>
             <a:prstGeom prst="rect">
               <a:avLst/>
@@ -46051,7 +45971,7 @@
             <a:p>
               <a:pPr algn="ctr"/>
               <a:r>
-                <a:rPr lang="zh-CN" sz="750" b="1" dirty="0">
+                <a:rPr lang="en-US" sz="750" b="1" dirty="0">
                   <a:solidFill>
                     <a:srgbClr val="FFFFFF"/>
                   </a:solidFill>
@@ -46370,16 +46290,16 @@
       </p:grpSp>
       <p:grpSp>
         <p:nvGrpSpPr>
-          <p:cNvPr id="33" name="Group 33"/>
+          <p:cNvPr id="33" name="exhibit-c-head"/>
           <p:cNvGrpSpPr/>
           <p:nvPr/>
         </p:nvGrpSpPr>
         <p:grpSpPr>
           <a:xfrm>
             <a:off x="452438" y="4581525"/>
-            <a:ext cx="3193710" cy="349091"/>
+            <a:ext cx="3056245" cy="349091"/>
             <a:chOff x="452438" y="4581525"/>
-            <a:chExt cx="3193710" cy="349091"/>
+            <a:chExt cx="3056245" cy="349091"/>
           </a:xfrm>
         </p:grpSpPr>
         <p:sp>
@@ -46412,8 +46332,8 @@
           </p:nvSpPr>
           <p:spPr>
             <a:xfrm>
-              <a:off x="497834" y="4610100"/>
-              <a:ext cx="71133" cy="147638"/>
+              <a:off x="490115" y="4610100"/>
+              <a:ext cx="86569" cy="147638"/>
             </a:xfrm>
             <a:prstGeom prst="rect">
               <a:avLst/>
@@ -46431,7 +46351,7 @@
             <a:p>
               <a:pPr algn="ctr"/>
               <a:r>
-                <a:rPr lang="zh-CN" sz="750" b="1" dirty="0">
+                <a:rPr lang="en-US" sz="750" b="1" dirty="0">
                   <a:solidFill>
                     <a:srgbClr val="FFFFFF"/>
                   </a:solidFill>
@@ -46493,7 +46413,7 @@
           <p:spPr>
             <a:xfrm>
               <a:off x="452438" y="4768691"/>
-              <a:ext cx="3193710" cy="161925"/>
+              <a:ext cx="3056245" cy="161925"/>
             </a:xfrm>
             <a:prstGeom prst="rect">
               <a:avLst/>
@@ -48145,8 +48065,8 @@
           </p:nvSpPr>
           <p:spPr>
             <a:xfrm>
-              <a:off x="8767184" y="1905000"/>
-              <a:ext cx="67832" cy="147638"/>
+              <a:off x="8768259" y="1905000"/>
+              <a:ext cx="65682" cy="147638"/>
             </a:xfrm>
             <a:prstGeom prst="rect">
               <a:avLst/>
@@ -48275,8 +48195,8 @@
           </p:nvSpPr>
           <p:spPr>
             <a:xfrm>
-              <a:off x="8767184" y="2628900"/>
-              <a:ext cx="67832" cy="147638"/>
+              <a:off x="8768259" y="2628900"/>
+              <a:ext cx="65682" cy="147638"/>
             </a:xfrm>
             <a:prstGeom prst="rect">
               <a:avLst/>
@@ -48405,8 +48325,8 @@
           </p:nvSpPr>
           <p:spPr>
             <a:xfrm>
-              <a:off x="8767184" y="3352800"/>
-              <a:ext cx="67832" cy="147638"/>
+              <a:off x="8768259" y="3352800"/>
+              <a:ext cx="65682" cy="147638"/>
             </a:xfrm>
             <a:prstGeom prst="rect">
               <a:avLst/>
@@ -48535,8 +48455,8 @@
           </p:nvSpPr>
           <p:spPr>
             <a:xfrm>
-              <a:off x="8767184" y="4076700"/>
-              <a:ext cx="67832" cy="147638"/>
+              <a:off x="8768259" y="4076700"/>
+              <a:ext cx="65682" cy="147638"/>
             </a:xfrm>
             <a:prstGeom prst="rect">
               <a:avLst/>
@@ -48790,7 +48710,7 @@
       </p:grpSp>
       <p:grpSp>
         <p:nvGrpSpPr>
-          <p:cNvPr id="58" name="Group 58"/>
+          <p:cNvPr id="58" name="footer"/>
           <p:cNvGrpSpPr/>
           <p:nvPr/>
         </p:nvGrpSpPr>
@@ -48811,7 +48731,7 @@
           <p:spPr>
             <a:xfrm>
               <a:off x="452438" y="6205538"/>
-              <a:ext cx="4244721" cy="147638"/>
+              <a:ext cx="4060412" cy="147638"/>
             </a:xfrm>
             <a:prstGeom prst="rect">
               <a:avLst/>
@@ -48851,7 +48771,7 @@
           <p:spPr>
             <a:xfrm>
               <a:off x="452438" y="6338888"/>
-              <a:ext cx="3401949" cy="147638"/>
+              <a:ext cx="3231642" cy="147638"/>
             </a:xfrm>
             <a:prstGeom prst="rect">
               <a:avLst/>
@@ -48891,7 +48811,7 @@
           <p:spPr>
             <a:xfrm>
               <a:off x="452438" y="6491288"/>
-              <a:ext cx="5731497" cy="147638"/>
+              <a:ext cx="5691664" cy="147638"/>
             </a:xfrm>
             <a:prstGeom prst="rect">
               <a:avLst/>
@@ -48930,8 +48850,8 @@
           </p:nvSpPr>
           <p:spPr>
             <a:xfrm>
-              <a:off x="11674507" y="6491288"/>
-              <a:ext cx="65056" cy="147638"/>
+              <a:off x="11673881" y="6491288"/>
+              <a:ext cx="65682" cy="147638"/>
             </a:xfrm>
             <a:prstGeom prst="rect">
               <a:avLst/>
@@ -49404,16 +49324,16 @@
       </p:grpSpPr>
       <p:grpSp>
         <p:nvGrpSpPr>
-          <p:cNvPr id="5" name="Group 5"/>
+          <p:cNvPr id="5" name="tracker"/>
           <p:cNvGrpSpPr/>
           <p:nvPr/>
         </p:nvGrpSpPr>
         <p:grpSpPr>
           <a:xfrm>
-            <a:off x="9926538" y="247650"/>
-            <a:ext cx="1808262" cy="206216"/>
-            <a:chOff x="9926538" y="247650"/>
-            <a:chExt cx="1808262" cy="206216"/>
+            <a:off x="9927681" y="247650"/>
+            <a:ext cx="1807119" cy="206216"/>
+            <a:chOff x="9927681" y="247650"/>
+            <a:chExt cx="1807119" cy="206216"/>
           </a:xfrm>
         </p:grpSpPr>
         <p:sp>
@@ -49424,8 +49344,8 @@
           </p:nvSpPr>
           <p:spPr>
             <a:xfrm>
-              <a:off x="9926538" y="291941"/>
-              <a:ext cx="879574" cy="161925"/>
+              <a:off x="9927681" y="291941"/>
+              <a:ext cx="878431" cy="161925"/>
             </a:xfrm>
             <a:prstGeom prst="rect">
               <a:avLst/>
@@ -49521,7 +49441,7 @@
       </p:grpSp>
       <p:grpSp>
         <p:nvGrpSpPr>
-          <p:cNvPr id="7" name="Group 7"/>
+          <p:cNvPr id="7" name="title"/>
           <p:cNvGrpSpPr/>
           <p:nvPr/>
         </p:nvGrpSpPr>
@@ -49592,16 +49512,16 @@
       </p:grpSp>
       <p:grpSp>
         <p:nvGrpSpPr>
-          <p:cNvPr id="9" name="Group 9"/>
+          <p:cNvPr id="9" name="unit-line"/>
           <p:cNvGrpSpPr/>
           <p:nvPr/>
         </p:nvGrpSpPr>
         <p:grpSpPr>
           <a:xfrm>
             <a:off x="452438" y="1160145"/>
-            <a:ext cx="7325639" cy="176212"/>
+            <a:ext cx="7115785" cy="176212"/>
             <a:chOff x="452438" y="1160145"/>
-            <a:chExt cx="7325639" cy="176212"/>
+            <a:chExt cx="7115785" cy="176212"/>
           </a:xfrm>
         </p:grpSpPr>
         <p:sp>
@@ -49613,7 +49533,7 @@
           <p:spPr>
             <a:xfrm>
               <a:off x="452438" y="1160145"/>
-              <a:ext cx="7325639" cy="176212"/>
+              <a:ext cx="7115785" cy="176212"/>
             </a:xfrm>
             <a:prstGeom prst="rect">
               <a:avLst/>
@@ -49683,16 +49603,16 @@
       </p:sp>
       <p:grpSp>
         <p:nvGrpSpPr>
-          <p:cNvPr id="15" name="Group 15"/>
+          <p:cNvPr id="15" name="exhibit-a-head"/>
           <p:cNvGrpSpPr/>
           <p:nvPr/>
         </p:nvGrpSpPr>
         <p:grpSpPr>
           <a:xfrm>
             <a:off x="452438" y="1552575"/>
-            <a:ext cx="1655384" cy="349091"/>
+            <a:ext cx="1618046" cy="349091"/>
             <a:chOff x="452438" y="1552575"/>
-            <a:chExt cx="1655384" cy="349091"/>
+            <a:chExt cx="1618046" cy="349091"/>
           </a:xfrm>
         </p:grpSpPr>
         <p:sp>
@@ -49725,8 +49645,8 @@
           </p:nvSpPr>
           <p:spPr>
             <a:xfrm>
-              <a:off x="497834" y="1581150"/>
-              <a:ext cx="71133" cy="147638"/>
+              <a:off x="490115" y="1581150"/>
+              <a:ext cx="86569" cy="147638"/>
             </a:xfrm>
             <a:prstGeom prst="rect">
               <a:avLst/>
@@ -49744,7 +49664,7 @@
             <a:p>
               <a:pPr algn="ctr"/>
               <a:r>
-                <a:rPr lang="zh-CN" sz="750" b="1" dirty="0">
+                <a:rPr lang="en-US" sz="750" b="1" dirty="0">
                   <a:solidFill>
                     <a:srgbClr val="FFFFFF"/>
                   </a:solidFill>
@@ -49766,7 +49686,7 @@
           <p:spPr>
             <a:xfrm>
               <a:off x="661797" y="1571149"/>
-              <a:ext cx="1446025" cy="190690"/>
+              <a:ext cx="1408687" cy="190690"/>
             </a:xfrm>
             <a:prstGeom prst="rect">
               <a:avLst/>
@@ -49949,7 +49869,7 @@
       </p:grpSp>
       <p:grpSp>
         <p:nvGrpSpPr>
-          <p:cNvPr id="30" name="Group 30"/>
+          <p:cNvPr id="30" name="powertrain-multiples"/>
           <p:cNvGrpSpPr/>
           <p:nvPr/>
         </p:nvGrpSpPr>
@@ -49970,7 +49890,7 @@
           <p:spPr>
             <a:xfrm>
               <a:off x="452438" y="4673441"/>
-              <a:ext cx="1071286" cy="161925"/>
+              <a:ext cx="1067857" cy="161925"/>
             </a:xfrm>
             <a:prstGeom prst="rect">
               <a:avLst/>
@@ -50046,7 +49966,7 @@
           <p:spPr>
             <a:xfrm>
               <a:off x="448818" y="4889182"/>
-              <a:ext cx="401592" cy="322707"/>
+              <a:ext cx="393573" cy="322707"/>
             </a:xfrm>
             <a:prstGeom prst="rect">
               <a:avLst/>
@@ -50086,7 +50006,7 @@
           <p:spPr>
             <a:xfrm>
               <a:off x="452438" y="5130641"/>
-              <a:ext cx="1082584" cy="161925"/>
+              <a:ext cx="1070087" cy="161925"/>
             </a:xfrm>
             <a:prstGeom prst="rect">
               <a:avLst/>
@@ -50126,7 +50046,7 @@
           <p:spPr>
             <a:xfrm>
               <a:off x="1410843" y="4889182"/>
-              <a:ext cx="273316" cy="322707"/>
+              <a:ext cx="270029" cy="322707"/>
             </a:xfrm>
             <a:prstGeom prst="rect">
               <a:avLst/>
@@ -50166,7 +50086,7 @@
           <p:spPr>
             <a:xfrm>
               <a:off x="1414462" y="5130641"/>
-              <a:ext cx="890133" cy="161925"/>
+              <a:ext cx="877636" cy="161925"/>
             </a:xfrm>
             <a:prstGeom prst="rect">
               <a:avLst/>
@@ -50206,7 +50126,7 @@
           <p:spPr>
             <a:xfrm>
               <a:off x="2372868" y="4889182"/>
-              <a:ext cx="529868" cy="322707"/>
+              <a:ext cx="455279" cy="322707"/>
             </a:xfrm>
             <a:prstGeom prst="rect">
               <a:avLst/>
@@ -50246,7 +50166,7 @@
           <p:spPr>
             <a:xfrm>
               <a:off x="2376488" y="5130641"/>
-              <a:ext cx="1018433" cy="161925"/>
+              <a:ext cx="1005937" cy="161925"/>
             </a:xfrm>
             <a:prstGeom prst="rect">
               <a:avLst/>
@@ -50286,7 +50206,7 @@
           <p:spPr>
             <a:xfrm>
               <a:off x="3334893" y="4889182"/>
-              <a:ext cx="529868" cy="322707"/>
+              <a:ext cx="455279" cy="322707"/>
             </a:xfrm>
             <a:prstGeom prst="rect">
               <a:avLst/>
@@ -50326,7 +50246,7 @@
           <p:spPr>
             <a:xfrm>
               <a:off x="3338512" y="5130641"/>
-              <a:ext cx="954283" cy="161925"/>
+              <a:ext cx="941786" cy="161925"/>
             </a:xfrm>
             <a:prstGeom prst="rect">
               <a:avLst/>
@@ -50360,7 +50280,7 @@
       </p:grpSp>
       <p:grpSp>
         <p:nvGrpSpPr>
-          <p:cNvPr id="32" name="Group 32"/>
+          <p:cNvPr id="32" name="powertrain-note"/>
           <p:cNvGrpSpPr/>
           <p:nvPr/>
         </p:nvGrpSpPr>
@@ -50443,16 +50363,16 @@
       </p:grpSp>
       <p:grpSp>
         <p:nvGrpSpPr>
-          <p:cNvPr id="37" name="Group 37"/>
+          <p:cNvPr id="37" name="exhibit-b-head"/>
           <p:cNvGrpSpPr/>
           <p:nvPr/>
         </p:nvGrpSpPr>
         <p:grpSpPr>
           <a:xfrm>
             <a:off x="4529138" y="1552575"/>
-            <a:ext cx="2102843" cy="349091"/>
+            <a:ext cx="2021539" cy="349091"/>
             <a:chOff x="4529138" y="1552575"/>
-            <a:chExt cx="2102843" cy="349091"/>
+            <a:chExt cx="2021539" cy="349091"/>
           </a:xfrm>
         </p:grpSpPr>
         <p:sp>
@@ -50485,8 +50405,8 @@
           </p:nvSpPr>
           <p:spPr>
             <a:xfrm>
-              <a:off x="4574534" y="1581150"/>
-              <a:ext cx="71133" cy="147638"/>
+              <a:off x="4566815" y="1581150"/>
+              <a:ext cx="86569" cy="147638"/>
             </a:xfrm>
             <a:prstGeom prst="rect">
               <a:avLst/>
@@ -50504,7 +50424,7 @@
             <a:p>
               <a:pPr algn="ctr"/>
               <a:r>
-                <a:rPr lang="zh-CN" sz="750" b="1" dirty="0">
+                <a:rPr lang="en-US" sz="750" b="1" dirty="0">
                   <a:solidFill>
                     <a:srgbClr val="FFFFFF"/>
                   </a:solidFill>
@@ -50526,7 +50446,7 @@
           <p:spPr>
             <a:xfrm>
               <a:off x="4738497" y="1571149"/>
-              <a:ext cx="1893484" cy="190690"/>
+              <a:ext cx="1812180" cy="190690"/>
             </a:xfrm>
             <a:prstGeom prst="rect">
               <a:avLst/>
@@ -50618,16 +50538,16 @@
       </p:graphicFrame>
       <p:grpSp>
         <p:nvGrpSpPr>
-          <p:cNvPr id="43" name="Group 43"/>
+          <p:cNvPr id="43" name="exhibit-c-head"/>
           <p:cNvGrpSpPr/>
           <p:nvPr/>
         </p:nvGrpSpPr>
         <p:grpSpPr>
           <a:xfrm>
             <a:off x="4529138" y="3705225"/>
-            <a:ext cx="1655384" cy="349091"/>
+            <a:ext cx="1618046" cy="349091"/>
             <a:chOff x="4529138" y="3705225"/>
-            <a:chExt cx="1655384" cy="349091"/>
+            <a:chExt cx="1618046" cy="349091"/>
           </a:xfrm>
         </p:grpSpPr>
         <p:sp>
@@ -50660,8 +50580,8 @@
           </p:nvSpPr>
           <p:spPr>
             <a:xfrm>
-              <a:off x="4574534" y="3733800"/>
-              <a:ext cx="71133" cy="147638"/>
+              <a:off x="4566815" y="3733800"/>
+              <a:ext cx="86569" cy="147638"/>
             </a:xfrm>
             <a:prstGeom prst="rect">
               <a:avLst/>
@@ -50679,7 +50599,7 @@
             <a:p>
               <a:pPr algn="ctr"/>
               <a:r>
-                <a:rPr lang="zh-CN" sz="750" b="1" dirty="0">
+                <a:rPr lang="en-US" sz="750" b="1" dirty="0">
                   <a:solidFill>
                     <a:srgbClr val="FFFFFF"/>
                   </a:solidFill>
@@ -50701,7 +50621,7 @@
           <p:spPr>
             <a:xfrm>
               <a:off x="4738497" y="3723799"/>
-              <a:ext cx="1446025" cy="190690"/>
+              <a:ext cx="1408687" cy="190690"/>
             </a:xfrm>
             <a:prstGeom prst="rect">
               <a:avLst/>
@@ -50911,8 +50831,8 @@
           </p:nvSpPr>
           <p:spPr>
             <a:xfrm>
-              <a:off x="8767184" y="1905000"/>
-              <a:ext cx="67832" cy="147638"/>
+              <a:off x="8768259" y="1905000"/>
+              <a:ext cx="65682" cy="147638"/>
             </a:xfrm>
             <a:prstGeom prst="rect">
               <a:avLst/>
@@ -51041,8 +50961,8 @@
           </p:nvSpPr>
           <p:spPr>
             <a:xfrm>
-              <a:off x="8767184" y="2628900"/>
-              <a:ext cx="67832" cy="147638"/>
+              <a:off x="8768259" y="2628900"/>
+              <a:ext cx="65682" cy="147638"/>
             </a:xfrm>
             <a:prstGeom prst="rect">
               <a:avLst/>
@@ -51171,8 +51091,8 @@
           </p:nvSpPr>
           <p:spPr>
             <a:xfrm>
-              <a:off x="8767184" y="3352800"/>
-              <a:ext cx="67832" cy="147638"/>
+              <a:off x="8768259" y="3352800"/>
+              <a:ext cx="65682" cy="147638"/>
             </a:xfrm>
             <a:prstGeom prst="rect">
               <a:avLst/>
@@ -51301,8 +51221,8 @@
           </p:nvSpPr>
           <p:spPr>
             <a:xfrm>
-              <a:off x="8767184" y="4076700"/>
-              <a:ext cx="67832" cy="147638"/>
+              <a:off x="8768259" y="4076700"/>
+              <a:ext cx="65682" cy="147638"/>
             </a:xfrm>
             <a:prstGeom prst="rect">
               <a:avLst/>
@@ -51556,7 +51476,7 @@
       </p:grpSp>
       <p:grpSp>
         <p:nvGrpSpPr>
-          <p:cNvPr id="68" name="Group 68"/>
+          <p:cNvPr id="68" name="footer"/>
           <p:cNvGrpSpPr/>
           <p:nvPr/>
         </p:nvGrpSpPr>
@@ -51577,7 +51497,7 @@
           <p:spPr>
             <a:xfrm>
               <a:off x="452438" y="6205538"/>
-              <a:ext cx="4244721" cy="147638"/>
+              <a:ext cx="4060412" cy="147638"/>
             </a:xfrm>
             <a:prstGeom prst="rect">
               <a:avLst/>
@@ -51617,7 +51537,7 @@
           <p:spPr>
             <a:xfrm>
               <a:off x="452438" y="6338888"/>
-              <a:ext cx="4986147" cy="147638"/>
+              <a:ext cx="4920139" cy="147638"/>
             </a:xfrm>
             <a:prstGeom prst="rect">
               <a:avLst/>
@@ -51657,7 +51577,7 @@
           <p:spPr>
             <a:xfrm>
               <a:off x="452438" y="6491288"/>
-              <a:ext cx="5731497" cy="147638"/>
+              <a:ext cx="5691664" cy="147638"/>
             </a:xfrm>
             <a:prstGeom prst="rect">
               <a:avLst/>
@@ -51696,8 +51616,8 @@
           </p:nvSpPr>
           <p:spPr>
             <a:xfrm>
-              <a:off x="11674507" y="6491288"/>
-              <a:ext cx="65056" cy="147638"/>
+              <a:off x="11673881" y="6491288"/>
+              <a:ext cx="65682" cy="147638"/>
             </a:xfrm>
             <a:prstGeom prst="rect">
               <a:avLst/>
@@ -52258,7 +52178,7 @@
       </p:grpSpPr>
       <p:grpSp>
         <p:nvGrpSpPr>
-          <p:cNvPr id="5" name="Group 5"/>
+          <p:cNvPr id="5" name="tracker"/>
           <p:cNvGrpSpPr/>
           <p:nvPr/>
         </p:nvGrpSpPr>
@@ -52375,7 +52295,7 @@
       </p:grpSp>
       <p:grpSp>
         <p:nvGrpSpPr>
-          <p:cNvPr id="7" name="Group 7"/>
+          <p:cNvPr id="7" name="title"/>
           <p:cNvGrpSpPr/>
           <p:nvPr/>
         </p:nvGrpSpPr>
@@ -52446,16 +52366,16 @@
       </p:grpSp>
       <p:grpSp>
         <p:nvGrpSpPr>
-          <p:cNvPr id="9" name="Group 9"/>
+          <p:cNvPr id="9" name="unit-line"/>
           <p:cNvGrpSpPr/>
           <p:nvPr/>
         </p:nvGrpSpPr>
         <p:grpSpPr>
           <a:xfrm>
             <a:off x="452438" y="1160145"/>
-            <a:ext cx="4547692" cy="176212"/>
+            <a:ext cx="4350182" cy="176212"/>
             <a:chOff x="452438" y="1160145"/>
-            <a:chExt cx="4547692" cy="176212"/>
+            <a:chExt cx="4350182" cy="176212"/>
           </a:xfrm>
         </p:grpSpPr>
         <p:sp>
@@ -52467,7 +52387,7 @@
           <p:spPr>
             <a:xfrm>
               <a:off x="452438" y="1160145"/>
-              <a:ext cx="4547692" cy="176212"/>
+              <a:ext cx="4350182" cy="176212"/>
             </a:xfrm>
             <a:prstGeom prst="rect">
               <a:avLst/>
@@ -52537,7 +52457,7 @@
       </p:sp>
       <p:grpSp>
         <p:nvGrpSpPr>
-          <p:cNvPr id="15" name="Group 15"/>
+          <p:cNvPr id="15" name="exhibit-a-head"/>
           <p:cNvGrpSpPr/>
           <p:nvPr/>
         </p:nvGrpSpPr>
@@ -52579,8 +52499,8 @@
           </p:nvSpPr>
           <p:spPr>
             <a:xfrm>
-              <a:off x="497834" y="1581150"/>
-              <a:ext cx="71133" cy="147638"/>
+              <a:off x="490115" y="1581150"/>
+              <a:ext cx="86569" cy="147638"/>
             </a:xfrm>
             <a:prstGeom prst="rect">
               <a:avLst/>
@@ -52598,7 +52518,7 @@
             <a:p>
               <a:pPr algn="ctr"/>
               <a:r>
-                <a:rPr lang="zh-CN" sz="750" b="1" dirty="0">
+                <a:rPr lang="en-US" sz="750" b="1" dirty="0">
                   <a:solidFill>
                     <a:srgbClr val="FFFFFF"/>
                   </a:solidFill>
@@ -53107,7 +53027,7 @@
       </p:grpSp>
       <p:grpSp>
         <p:nvGrpSpPr>
-          <p:cNvPr id="40" name="Group 40"/>
+          <p:cNvPr id="40" name="increment-share"/>
           <p:cNvGrpSpPr/>
           <p:nvPr/>
         </p:nvGrpSpPr>
@@ -53203,8 +53123,8 @@
           </p:nvSpPr>
           <p:spPr>
             <a:xfrm>
-              <a:off x="1295419" y="4208145"/>
-              <a:ext cx="76162" cy="176212"/>
+              <a:off x="1268158" y="4208145"/>
+              <a:ext cx="130683" cy="176212"/>
             </a:xfrm>
             <a:prstGeom prst="rect">
               <a:avLst/>
@@ -53243,8 +53163,8 @@
           </p:nvSpPr>
           <p:spPr>
             <a:xfrm>
-              <a:off x="1992113" y="4208145"/>
-              <a:ext cx="244874" cy="176212"/>
+              <a:off x="1988533" y="4208145"/>
+              <a:ext cx="252035" cy="176212"/>
             </a:xfrm>
             <a:prstGeom prst="rect">
               <a:avLst/>
@@ -53283,8 +53203,8 @@
           </p:nvSpPr>
           <p:spPr>
             <a:xfrm>
-              <a:off x="2773163" y="4208145"/>
-              <a:ext cx="244874" cy="176212"/>
+              <a:off x="2769583" y="4208145"/>
+              <a:ext cx="252035" cy="176212"/>
             </a:xfrm>
             <a:prstGeom prst="rect">
               <a:avLst/>
@@ -53323,8 +53243,8 @@
           </p:nvSpPr>
           <p:spPr>
             <a:xfrm>
-              <a:off x="3589197" y="4208145"/>
-              <a:ext cx="174906" cy="176212"/>
+              <a:off x="3584327" y="4208145"/>
+              <a:ext cx="184647" cy="176212"/>
             </a:xfrm>
             <a:prstGeom prst="rect">
               <a:avLst/>
@@ -53363,8 +53283,8 @@
           </p:nvSpPr>
           <p:spPr>
             <a:xfrm>
-              <a:off x="4370247" y="4208145"/>
-              <a:ext cx="174906" cy="176212"/>
+              <a:off x="4365377" y="4208145"/>
+              <a:ext cx="184647" cy="176212"/>
             </a:xfrm>
             <a:prstGeom prst="rect">
               <a:avLst/>
@@ -53403,8 +53323,8 @@
           </p:nvSpPr>
           <p:spPr>
             <a:xfrm>
-              <a:off x="5151297" y="4208145"/>
-              <a:ext cx="174906" cy="176212"/>
+              <a:off x="5146427" y="4208145"/>
+              <a:ext cx="184647" cy="176212"/>
             </a:xfrm>
             <a:prstGeom prst="rect">
               <a:avLst/>
@@ -53443,8 +53363,8 @@
           </p:nvSpPr>
           <p:spPr>
             <a:xfrm>
-              <a:off x="5936285" y="4208145"/>
-              <a:ext cx="167030" cy="176212"/>
+              <a:off x="5927477" y="4208145"/>
+              <a:ext cx="184647" cy="176212"/>
             </a:xfrm>
             <a:prstGeom prst="rect">
               <a:avLst/>
@@ -53483,8 +53403,8 @@
           </p:nvSpPr>
           <p:spPr>
             <a:xfrm>
-              <a:off x="6717335" y="4208145"/>
-              <a:ext cx="167030" cy="176212"/>
+              <a:off x="6708527" y="4208145"/>
+              <a:ext cx="184647" cy="176212"/>
             </a:xfrm>
             <a:prstGeom prst="rect">
               <a:avLst/>
@@ -53523,8 +53443,8 @@
           </p:nvSpPr>
           <p:spPr>
             <a:xfrm>
-              <a:off x="7465066" y="4208145"/>
-              <a:ext cx="233667" cy="176212"/>
+              <a:off x="7455883" y="4208145"/>
+              <a:ext cx="252035" cy="176212"/>
             </a:xfrm>
             <a:prstGeom prst="rect">
               <a:avLst/>
@@ -53563,8 +53483,8 @@
           </p:nvSpPr>
           <p:spPr>
             <a:xfrm>
-              <a:off x="8324869" y="4208145"/>
-              <a:ext cx="76162" cy="176212"/>
+              <a:off x="8297608" y="4208145"/>
+              <a:ext cx="130683" cy="176212"/>
             </a:xfrm>
             <a:prstGeom prst="rect">
               <a:avLst/>
@@ -53598,7 +53518,7 @@
       </p:grpSp>
       <p:grpSp>
         <p:nvGrpSpPr>
-          <p:cNvPr id="45" name="Group 45"/>
+          <p:cNvPr id="45" name="exhibit-b-head"/>
           <p:cNvGrpSpPr/>
           <p:nvPr/>
         </p:nvGrpSpPr>
@@ -53640,8 +53560,8 @@
           </p:nvSpPr>
           <p:spPr>
             <a:xfrm>
-              <a:off x="497834" y="4533900"/>
-              <a:ext cx="71133" cy="147638"/>
+              <a:off x="490115" y="4533900"/>
+              <a:ext cx="86569" cy="147638"/>
             </a:xfrm>
             <a:prstGeom prst="rect">
               <a:avLst/>
@@ -53659,7 +53579,7 @@
             <a:p>
               <a:pPr algn="ctr"/>
               <a:r>
-                <a:rPr lang="zh-CN" sz="750" b="1" dirty="0">
+                <a:rPr lang="en-US" sz="750" b="1" dirty="0">
                   <a:solidFill>
                     <a:srgbClr val="FFFFFF"/>
                   </a:solidFill>
@@ -55373,8 +55293,8 @@
           </p:nvSpPr>
           <p:spPr>
             <a:xfrm>
-              <a:off x="8767184" y="1905000"/>
-              <a:ext cx="67832" cy="147638"/>
+              <a:off x="8768259" y="1905000"/>
+              <a:ext cx="65682" cy="147638"/>
             </a:xfrm>
             <a:prstGeom prst="rect">
               <a:avLst/>
@@ -55503,8 +55423,8 @@
           </p:nvSpPr>
           <p:spPr>
             <a:xfrm>
-              <a:off x="8767184" y="2628900"/>
-              <a:ext cx="67832" cy="147638"/>
+              <a:off x="8768259" y="2628900"/>
+              <a:ext cx="65682" cy="147638"/>
             </a:xfrm>
             <a:prstGeom prst="rect">
               <a:avLst/>
@@ -55633,8 +55553,8 @@
           </p:nvSpPr>
           <p:spPr>
             <a:xfrm>
-              <a:off x="8767184" y="3352800"/>
-              <a:ext cx="67832" cy="147638"/>
+              <a:off x="8768259" y="3352800"/>
+              <a:ext cx="65682" cy="147638"/>
             </a:xfrm>
             <a:prstGeom prst="rect">
               <a:avLst/>
@@ -55763,8 +55683,8 @@
           </p:nvSpPr>
           <p:spPr>
             <a:xfrm>
-              <a:off x="8767184" y="4076700"/>
-              <a:ext cx="67832" cy="147638"/>
+              <a:off x="8768259" y="4076700"/>
+              <a:ext cx="65682" cy="147638"/>
             </a:xfrm>
             <a:prstGeom prst="rect">
               <a:avLst/>
@@ -56018,7 +55938,7 @@
       </p:grpSp>
       <p:grpSp>
         <p:nvGrpSpPr>
-          <p:cNvPr id="70" name="Group 70"/>
+          <p:cNvPr id="70" name="footer"/>
           <p:cNvGrpSpPr/>
           <p:nvPr/>
         </p:nvGrpSpPr>
@@ -56039,7 +55959,7 @@
           <p:spPr>
             <a:xfrm>
               <a:off x="452438" y="6205538"/>
-              <a:ext cx="5241036" cy="147638"/>
+              <a:ext cx="5175361" cy="147638"/>
             </a:xfrm>
             <a:prstGeom prst="rect">
               <a:avLst/>
@@ -56119,7 +56039,7 @@
           <p:spPr>
             <a:xfrm>
               <a:off x="452438" y="6491288"/>
-              <a:ext cx="5731497" cy="147638"/>
+              <a:ext cx="5691664" cy="147638"/>
             </a:xfrm>
             <a:prstGeom prst="rect">
               <a:avLst/>
@@ -56158,8 +56078,8 @@
           </p:nvSpPr>
           <p:spPr>
             <a:xfrm>
-              <a:off x="11674507" y="6491288"/>
-              <a:ext cx="65056" cy="147638"/>
+              <a:off x="11673881" y="6491288"/>
+              <a:ext cx="65682" cy="147638"/>
             </a:xfrm>
             <a:prstGeom prst="rect">
               <a:avLst/>

</xml_diff>